<commit_message>
Finalize verified Aktina competition pack and silent demo
</commit_message>
<xml_diff>
--- a/app/delivery/Aktina-Pafos-2026.pptx
+++ b/app/delivery/Aktina-Pafos-2026.pptx
@@ -2,24 +2,24 @@
 <file path=ppt/presentation.xml><?xml version="1.0" encoding="utf-8"?>
 <p:presentation xmlns:p="http://schemas.openxmlformats.org/presentationml/2006/main">
   <p:sldMasterIdLst>
-    <p:sldMasterId xmlns:r="http://schemas.openxmlformats.org/officeDocument/2006/relationships" id="2147483648" r:id="Ref3553c5c2674b2b"/>
+    <p:sldMasterId xmlns:r="http://schemas.openxmlformats.org/officeDocument/2006/relationships" id="2147483648" r:id="Rdd8190bb43ff4ce8"/>
   </p:sldMasterIdLst>
   <p:notesMasterIdLst>
-    <p:notesMasterId xmlns:r="http://schemas.openxmlformats.org/officeDocument/2006/relationships" r:id="R3a10625ea4434678"/>
+    <p:notesMasterId xmlns:r="http://schemas.openxmlformats.org/officeDocument/2006/relationships" r:id="R6c14cfd3511f4b78"/>
   </p:notesMasterIdLst>
   <p:sldIdLst>
-    <p:sldId xmlns:r="http://schemas.openxmlformats.org/officeDocument/2006/relationships" id="256" r:id="R265141771e774ac9"/>
-    <p:sldId xmlns:r="http://schemas.openxmlformats.org/officeDocument/2006/relationships" id="257" r:id="R3f62e88c015c4582"/>
-    <p:sldId xmlns:r="http://schemas.openxmlformats.org/officeDocument/2006/relationships" id="258" r:id="R7d55d9eb2a2742e1"/>
-    <p:sldId xmlns:r="http://schemas.openxmlformats.org/officeDocument/2006/relationships" id="259" r:id="Rb2017f3bfbe74567"/>
-    <p:sldId xmlns:r="http://schemas.openxmlformats.org/officeDocument/2006/relationships" id="260" r:id="R05e992859fe943f1"/>
-    <p:sldId xmlns:r="http://schemas.openxmlformats.org/officeDocument/2006/relationships" id="261" r:id="Rb0491c84c3954387"/>
-    <p:sldId xmlns:r="http://schemas.openxmlformats.org/officeDocument/2006/relationships" id="262" r:id="Rbb377ba4c7dd48b9"/>
-    <p:sldId xmlns:r="http://schemas.openxmlformats.org/officeDocument/2006/relationships" id="263" r:id="R3dbbe080e4084458"/>
-    <p:sldId xmlns:r="http://schemas.openxmlformats.org/officeDocument/2006/relationships" id="264" r:id="Rd5de162adce64184"/>
-    <p:sldId xmlns:r="http://schemas.openxmlformats.org/officeDocument/2006/relationships" id="265" r:id="R1f3a8a436f514d02"/>
-    <p:sldId xmlns:r="http://schemas.openxmlformats.org/officeDocument/2006/relationships" id="266" r:id="R4fcba2aef6ad4076"/>
-    <p:sldId xmlns:r="http://schemas.openxmlformats.org/officeDocument/2006/relationships" id="267" r:id="R318374cf55f5416e"/>
+    <p:sldId xmlns:r="http://schemas.openxmlformats.org/officeDocument/2006/relationships" id="256" r:id="Rdd32b86cb03b4a3c"/>
+    <p:sldId xmlns:r="http://schemas.openxmlformats.org/officeDocument/2006/relationships" id="257" r:id="Rfad8e00a619b44c7"/>
+    <p:sldId xmlns:r="http://schemas.openxmlformats.org/officeDocument/2006/relationships" id="258" r:id="R2fd088a54f7a4e53"/>
+    <p:sldId xmlns:r="http://schemas.openxmlformats.org/officeDocument/2006/relationships" id="259" r:id="R79a1bc272f9349e9"/>
+    <p:sldId xmlns:r="http://schemas.openxmlformats.org/officeDocument/2006/relationships" id="260" r:id="R09b26e99dc8d4c93"/>
+    <p:sldId xmlns:r="http://schemas.openxmlformats.org/officeDocument/2006/relationships" id="261" r:id="Rf4d89237e1ea491e"/>
+    <p:sldId xmlns:r="http://schemas.openxmlformats.org/officeDocument/2006/relationships" id="262" r:id="R953ab84bab5c404a"/>
+    <p:sldId xmlns:r="http://schemas.openxmlformats.org/officeDocument/2006/relationships" id="263" r:id="R3fc7d60994a14251"/>
+    <p:sldId xmlns:r="http://schemas.openxmlformats.org/officeDocument/2006/relationships" id="264" r:id="R1a72e22aa8724a00"/>
+    <p:sldId xmlns:r="http://schemas.openxmlformats.org/officeDocument/2006/relationships" id="265" r:id="R64136b0054e44a0a"/>
+    <p:sldId xmlns:r="http://schemas.openxmlformats.org/officeDocument/2006/relationships" id="266" r:id="R9ec9492cf5724788"/>
+    <p:sldId xmlns:r="http://schemas.openxmlformats.org/officeDocument/2006/relationships" id="267" r:id="R4200c0cedd204dd3"/>
   </p:sldIdLst>
   <p:sldSz cx="12192000" cy="6858000"/>
   <p:notesSz cx="6858000" cy="9144000"/>
@@ -1428,7 +1428,7 @@
           </a:p>
           <a:p xmlns:a="http://schemas.openxmlformats.org/drawingml/2006/main">
             <a:r>
-              <a:t>- Open **AktinaBench**; show the original test comparison, then the direct classifier's precision/recall tradeoff.</a:t>
+              <a:t>- Open **AktinaBench**; show the original test comparison, then select **Archived weather forecast** and **Weather + past errors**.</a:t>
             </a:r>
           </a:p>
           <a:p xmlns:a="http://schemas.openxmlformats.org/drawingml/2006/main">
@@ -1438,7 +1438,7 @@
           </a:p>
           <a:p xmlns:a="http://schemas.openxmlformats.org/drawingml/2006/main">
             <a:r>
-              <a:t>Fallback: `Aktina-Backup-v2.mp4`, 60 seconds, no audio. It is a screenshot walkthrough, not a live interaction recording. Do not play both sequences. Online address: https://aktina-pafos-2026.vercel.app/.</a:t>
+              <a:t>Fallback: `Aktina-Backup-Final.mp4`, 44 seconds, no audio. It is a product screenshot walkthrough, not a live interaction recording. Do not play both sequences. Online address: https://aktina-pafos-2026.vercel.app/.</a:t>
             </a:r>
           </a:p>
           <a:p xmlns:a="http://schemas.openxmlformats.org/drawingml/2006/main">
@@ -1648,7 +1648,7 @@
           <a:lstStyle xmlns:a="http://schemas.openxmlformats.org/drawingml/2006/main"/>
           <a:p xmlns:a="http://schemas.openxmlformats.org/drawingml/2006/main">
             <a:r>
-              <a:t>SLIDE 8: More detections, more false alarms</a:t>
+              <a:t>SLIDE 8: Archived weather inputs</a:t>
             </a:r>
           </a:p>
           <a:p xmlns:a="http://schemas.openxmlformats.org/drawingml/2006/main">
@@ -1668,7 +1668,7 @@
           </a:p>
           <a:p xmlns:a="http://schemas.openxmlformats.org/drawingml/2006/main">
             <a:r>
-              <a:t>We ran six separate fixed experiments while preserving the original model. The validation-selected direct classifier misses 15 positive test hours instead of persistence's 25. But it raises false alarms from 20 to 37, lowering precision from 98.01 to 96.41 percent. Its F1 remains lower than persistence. The neural candidate also loses.</a:t>
+              <a:t>The strongest completed progress comes from additional weather information. On the same 3,567 original test hours, the original model has MAE 14.27 W/m². The fixed archived day2 forecast has MAE 8.81, and raw residual analogues reduce it to 6.92. Precision, recall and F1 are 97.57%, 95.54%, 96.55% for the original model; 98.51%, 98.32%, 98.41% for the archived forecast; and 98.41%, 98.32%, 98.37% for the raw analogue. These are retrospective comparisons against the original model-derived reference.</a:t>
             </a:r>
           </a:p>
           <a:p xmlns:a="http://schemas.openxmlformats.org/drawingml/2006/main">
@@ -1678,7 +1678,7 @@
           </a:p>
           <a:p xmlns:a="http://schemas.openxmlformats.org/drawingml/2006/main">
             <a:r>
-              <a:t>The roadmap prioritises precision because a false surplus prediction can be costly. Higher recall alone is not enough to promote this candidate. The experiments purge 24 hours at the training boundary, but this test period was already inspected. We need fresh held-out evidence before claiming a better next model.</a:t>
+              <a:t>The analogue reuses 64 historical residuals to form hourly scenarios. Its lower MAE comes with one extra false alarm: 16 instead of the archived forecast's 15, with 17 misses for both. Validation retains the fixed archived forecast. On the harder 3,566-hour validation period its F1 is 90.08%, compared with 80.07% for the original model and 89.95% for raw analogues. No learned candidate is promoted. The original model remains intact.</a:t>
             </a:r>
           </a:p>
           <a:p xmlns:a="http://schemas.openxmlformats.org/drawingml/2006/main">
@@ -1688,7 +1688,27 @@
           </a:p>
           <a:p xmlns:a="http://schemas.openxmlformats.org/drawingml/2006/main">
             <a:r>
-              <a:t>Source cue: `app/experiments/f1-001/README.md`. Direct classifier: F1 0.974535, precision 0.964147, recall 0.985149; persistence: 0.977667, 0.980100, 0.975248. No candidate wins all three.</a:t>
+              <a:t>We also checked the same fixed forecasts against the SARAH3 satellite estimate. On 3,517 common test hours, with 50 missing reference hours retained as unscored, archived-forecast F1 is 96.59% and raw-analogue F1 is 96.54%. MAE is 19.33 versus 18.23 W/m², while false alarms rise from 42 to 43. The harder satellite validation gives the archived forecast F1 of 80.71% on 3,419 common hours. The reference changes the apparent accuracy, so the near-99% weather-reference scores cannot stand alone.</a:t>
+            </a:r>
+          </a:p>
+          <a:p xmlns:a="http://schemas.openxmlformats.org/drawingml/2006/main">
+            <a:r>
+              <a:t/>
+            </a:r>
+          </a:p>
+          <a:p xmlns:a="http://schemas.openxmlformats.org/drawingml/2006/main">
+            <a:r>
+              <a:t>These tests were already inspected during development. Historical forecast publication times are unverified, and satellite estimates are not local ground-sensor measurements. We have separately locked 48 future forecast hours for later satellite evaluation, with no outcomes scored yet. This is evidence to review with Stefanos, not a claim of live superiority, measured curtailment recovery or field savings.</a:t>
+            </a:r>
+          </a:p>
+          <a:p xmlns:a="http://schemas.openxmlformats.org/drawingml/2006/main">
+            <a:r>
+              <a:t/>
+            </a:r>
+          </a:p>
+          <a:p xmlns:a="http://schemas.openxmlformats.org/drawingml/2006/main">
+            <a:r>
+              <a:t>Source cue: `app/experiments/f1-004/result/comparison.csv` (fixed defaults, full test), `app/experiments/reference-sensitivity-001/result-amended/metrics.csv` (identical common-hour bases), and the frozen prospective capture. The fixed 600 W/m² event remains a radiation proxy. Analogue decisions use scenario probability strictly above 0.5. Keep original, archived-control and synthesis results distinct.</a:t>
             </a:r>
           </a:p>
           <a:p xmlns:a="http://schemas.openxmlformats.org/drawingml/2006/main">
@@ -1886,7 +1906,7 @@
   </p:cSld>
   <p:clrMap bg1="lt1" tx1="dk1" bg2="lt2" tx2="dk2" accent1="accent1" accent2="accent2" accent3="accent3" accent4="accent4" accent5="accent5" accent6="accent6" hlink="hlink" folHlink="folHlink"/>
   <p:sldLayoutIdLst>
-    <p:sldLayoutId xmlns:r="http://schemas.openxmlformats.org/officeDocument/2006/relationships" id="2147483649" r:id="R3ee7606006de4f1b"/>
+    <p:sldLayoutId xmlns:r="http://schemas.openxmlformats.org/officeDocument/2006/relationships" id="2147483649" r:id="R7801477d537245a7"/>
   </p:sldLayoutIdLst>
   <p:txStyles>
     <p:titleStyle>
@@ -3691,38 +3711,32 @@
           <c:idx val="0"/>
           <c:order val="0"/>
           <c:tx>
-            <c:v>Persistence</c:v>
+            <c:v>Original</c:v>
           </c:tx>
           <c:spPr>
             <a:solidFill xmlns:a="http://schemas.openxmlformats.org/drawingml/2006/main">
-              <a:srgbClr val="999999"/>
+              <a:srgbClr val="BBBBBB"/>
             </a:solidFill>
           </c:spPr>
           <c:cat>
             <c:strRef>
-              <c:f>'Chart Data'!$A$2:$A$3</c:f>
+              <c:f>'Chart Data'!$A$2:$A$2</c:f>
               <c:strCache>
-                <c:ptCount val="2"/>
+                <c:ptCount val="1"/>
                 <c:pt idx="0">
-                  <c:v>Missed positive hours</c:v>
-                </c:pt>
-                <c:pt idx="1">
-                  <c:v>False alarms</c:v>
+                  <c:v>MAE, W/m²</c:v>
                 </c:pt>
               </c:strCache>
             </c:strRef>
           </c:cat>
           <c:val>
             <c:numRef>
-              <c:f>'Chart Data'!$B$2:$B$3</c:f>
+              <c:f>'Chart Data'!$B$2:$B$2</c:f>
               <c:numCache>
-                <c:formatCode>0</c:formatCode>
-                <c:ptCount val="2"/>
+                <c:formatCode>0.00</c:formatCode>
+                <c:ptCount val="1"/>
                 <c:pt idx="0">
-                  <c:v>25</c:v>
-                </c:pt>
-                <c:pt idx="1">
-                  <c:v>20</c:v>
+                  <c:v>14.265815</c:v>
                 </c:pt>
               </c:numCache>
             </c:numRef>
@@ -3732,7 +3746,42 @@
           <c:idx val="1"/>
           <c:order val="1"/>
           <c:tx>
-            <c:v>Direct classifier</c:v>
+            <c:v>Day2 forecast</c:v>
+          </c:tx>
+          <c:spPr>
+            <a:solidFill xmlns:a="http://schemas.openxmlformats.org/drawingml/2006/main">
+              <a:srgbClr val="777777"/>
+            </a:solidFill>
+          </c:spPr>
+          <c:cat>
+            <c:strRef>
+              <c:f>'Chart Data'!$C$2:$C$2</c:f>
+              <c:strCache>
+                <c:ptCount val="1"/>
+                <c:pt idx="0">
+                  <c:v>MAE, W/m²</c:v>
+                </c:pt>
+              </c:strCache>
+            </c:strRef>
+          </c:cat>
+          <c:val>
+            <c:numRef>
+              <c:f>'Chart Data'!$D$2:$D$2</c:f>
+              <c:numCache>
+                <c:formatCode>0.00</c:formatCode>
+                <c:ptCount val="1"/>
+                <c:pt idx="0">
+                  <c:v>8.805719</c:v>
+                </c:pt>
+              </c:numCache>
+            </c:numRef>
+          </c:val>
+        </c:ser>
+        <c:ser>
+          <c:idx val="2"/>
+          <c:order val="2"/>
+          <c:tx>
+            <c:v>Raw analogue</c:v>
           </c:tx>
           <c:spPr>
             <a:solidFill xmlns:a="http://schemas.openxmlformats.org/drawingml/2006/main">
@@ -3741,29 +3790,23 @@
           </c:spPr>
           <c:cat>
             <c:strRef>
-              <c:f>'Chart Data'!$C$2:$C$3</c:f>
+              <c:f>'Chart Data'!$E$2:$E$2</c:f>
               <c:strCache>
-                <c:ptCount val="2"/>
+                <c:ptCount val="1"/>
                 <c:pt idx="0">
-                  <c:v>Missed positive hours</c:v>
-                </c:pt>
-                <c:pt idx="1">
-                  <c:v>False alarms</c:v>
+                  <c:v>MAE, W/m²</c:v>
                 </c:pt>
               </c:strCache>
             </c:strRef>
           </c:cat>
           <c:val>
             <c:numRef>
-              <c:f>'Chart Data'!$D$2:$D$3</c:f>
+              <c:f>'Chart Data'!$F$2:$F$2</c:f>
               <c:numCache>
-                <c:formatCode>0</c:formatCode>
-                <c:ptCount val="2"/>
+                <c:formatCode>0.00</c:formatCode>
+                <c:ptCount val="1"/>
                 <c:pt idx="0">
-                  <c:v>15</c:v>
-                </c:pt>
-                <c:pt idx="1">
-                  <c:v>37</c:v>
+                  <c:v>6.921082</c:v>
                 </c:pt>
               </c:numCache>
             </c:numRef>
@@ -3838,7 +3881,7 @@
         <c:axId val="48672768"/>
         <c:scaling>
           <c:orientation val="minMax"/>
-          <c:max val="40"/>
+          <c:max val="16"/>
           <c:min val="0"/>
         </c:scaling>
         <c:delete val="0"/>
@@ -3881,7 +3924,7 @@
         </c:txPr>
         <c:crossAx val="48650112"/>
         <c:crossBetween val="between"/>
-        <c:majorUnit val="10"/>
+        <c:majorUnit val="4"/>
       </c:valAx>
       <c:spPr>
         <a:noFill xmlns:a="http://schemas.openxmlformats.org/drawingml/2006/main"/>
@@ -3898,7 +3941,7 @@
         <a:lstStyle xmlns:a="http://schemas.openxmlformats.org/drawingml/2006/main"/>
         <a:p xmlns:a="http://schemas.openxmlformats.org/drawingml/2006/main">
           <a:pPr>
-            <a:defRPr sz="1500">
+            <a:defRPr sz="1350">
               <a:solidFill>
                 <a:srgbClr val="141414"/>
               </a:solidFill>
@@ -4006,7 +4049,7 @@
           <p:cNvPr id="8" name="">
             <a:extLst xmlns:a="http://schemas.openxmlformats.org/drawingml/2006/main">
               <a:ext uri="{FF2B5EF4-FFF2-40B4-BE49-F238E27FC236}">
-                <a16:creationId xmlns:a16="http://schemas.microsoft.com/office/drawing/2014/main" id="{5DDAFDB1-3F56-4986-842F-91E42579FC05}"/>
+                <a16:creationId xmlns:a16="http://schemas.microsoft.com/office/drawing/2014/main" id="{43BF777E-9F57-473C-A3C9-28F2F9753FCB}"/>
               </a:ext>
             </a:extLst>
           </p:cNvPr>
@@ -4063,7 +4106,7 @@
           <p:cNvPr id="9" name="">
             <a:extLst xmlns:a="http://schemas.openxmlformats.org/drawingml/2006/main">
               <a:ext uri="{FF2B5EF4-FFF2-40B4-BE49-F238E27FC236}">
-                <a16:creationId xmlns:a16="http://schemas.microsoft.com/office/drawing/2014/main" id="{1BB37A81-A5EE-4F3A-85B4-15B19659FA88}"/>
+                <a16:creationId xmlns:a16="http://schemas.microsoft.com/office/drawing/2014/main" id="{1D1F34AE-6953-4E72-99EC-8759854E3569}"/>
               </a:ext>
             </a:extLst>
           </p:cNvPr>
@@ -4143,7 +4186,7 @@
           <p:cNvPr id="10" name="">
             <a:extLst xmlns:a="http://schemas.openxmlformats.org/drawingml/2006/main">
               <a:ext uri="{FF2B5EF4-FFF2-40B4-BE49-F238E27FC236}">
-                <a16:creationId xmlns:a16="http://schemas.microsoft.com/office/drawing/2014/main" id="{7C9D743C-22E4-45BA-9BA6-7640694E137D}"/>
+                <a16:creationId xmlns:a16="http://schemas.microsoft.com/office/drawing/2014/main" id="{23B99550-EA0C-4EAB-A7A6-F014451DF4D4}"/>
               </a:ext>
             </a:extLst>
           </p:cNvPr>
@@ -4200,7 +4243,7 @@
           <p:cNvPr id="11" name="">
             <a:extLst xmlns:a="http://schemas.openxmlformats.org/drawingml/2006/main">
               <a:ext uri="{FF2B5EF4-FFF2-40B4-BE49-F238E27FC236}">
-                <a16:creationId xmlns:a16="http://schemas.microsoft.com/office/drawing/2014/main" id="{A4117CD7-CD14-4AF4-93EA-9536CA471F7F}"/>
+                <a16:creationId xmlns:a16="http://schemas.microsoft.com/office/drawing/2014/main" id="{2538F9F1-AD11-479C-90A2-886FA940449E}"/>
               </a:ext>
             </a:extLst>
           </p:cNvPr>
@@ -4425,7 +4468,7 @@
           <p:cNvPr id="9" name="">
             <a:extLst xmlns:a="http://schemas.openxmlformats.org/drawingml/2006/main">
               <a:ext uri="{FF2B5EF4-FFF2-40B4-BE49-F238E27FC236}">
-                <a16:creationId xmlns:a16="http://schemas.microsoft.com/office/drawing/2014/main" id="{8520214C-C70B-4F6C-A667-0887259FBBDF}"/>
+                <a16:creationId xmlns:a16="http://schemas.microsoft.com/office/drawing/2014/main" id="{E0289C5B-F284-45A9-BF94-3BB3868A32B0}"/>
               </a:ext>
             </a:extLst>
           </p:cNvPr>
@@ -4482,7 +4525,7 @@
           <p:cNvPr id="10" name="">
             <a:extLst xmlns:a="http://schemas.openxmlformats.org/drawingml/2006/main">
               <a:ext uri="{FF2B5EF4-FFF2-40B4-BE49-F238E27FC236}">
-                <a16:creationId xmlns:a16="http://schemas.microsoft.com/office/drawing/2014/main" id="{DA00EF53-B46C-43F4-8359-40108EE79284}"/>
+                <a16:creationId xmlns:a16="http://schemas.microsoft.com/office/drawing/2014/main" id="{8CA7DC03-7151-4A0D-B240-C776B45DB1B0}"/>
               </a:ext>
             </a:extLst>
           </p:cNvPr>
@@ -4608,7 +4651,7 @@
           <p:cNvPr id="11" name="">
             <a:extLst xmlns:a="http://schemas.openxmlformats.org/drawingml/2006/main">
               <a:ext uri="{FF2B5EF4-FFF2-40B4-BE49-F238E27FC236}">
-                <a16:creationId xmlns:a16="http://schemas.microsoft.com/office/drawing/2014/main" id="{05123F2E-3C77-4BA2-9F01-86299AC7BBCF}"/>
+                <a16:creationId xmlns:a16="http://schemas.microsoft.com/office/drawing/2014/main" id="{2F842AAF-8387-4F30-8E7C-7C54E07F7A50}"/>
               </a:ext>
             </a:extLst>
           </p:cNvPr>
@@ -4665,7 +4708,7 @@
           <p:cNvPr id="12" name="">
             <a:extLst xmlns:a="http://schemas.openxmlformats.org/drawingml/2006/main">
               <a:ext uri="{FF2B5EF4-FFF2-40B4-BE49-F238E27FC236}">
-                <a16:creationId xmlns:a16="http://schemas.microsoft.com/office/drawing/2014/main" id="{C49194ED-4E86-45BF-BA5F-6E96C46BEE24}"/>
+                <a16:creationId xmlns:a16="http://schemas.microsoft.com/office/drawing/2014/main" id="{00DD8D04-D524-45A0-85C9-9D846FF9335D}"/>
               </a:ext>
             </a:extLst>
           </p:cNvPr>
@@ -4791,7 +4834,7 @@
           <p:cNvPr id="13" name="">
             <a:extLst xmlns:a="http://schemas.openxmlformats.org/drawingml/2006/main">
               <a:ext uri="{FF2B5EF4-FFF2-40B4-BE49-F238E27FC236}">
-                <a16:creationId xmlns:a16="http://schemas.microsoft.com/office/drawing/2014/main" id="{CE2FF9C4-4BAA-4206-8C5F-94B1C12866F8}"/>
+                <a16:creationId xmlns:a16="http://schemas.microsoft.com/office/drawing/2014/main" id="{8EB16AF2-ABD5-4865-9BD1-E688EE736743}"/>
               </a:ext>
             </a:extLst>
           </p:cNvPr>
@@ -4993,7 +5036,7 @@
           <p:cNvPr id="16" name="">
             <a:extLst xmlns:a="http://schemas.openxmlformats.org/drawingml/2006/main">
               <a:ext uri="{FF2B5EF4-FFF2-40B4-BE49-F238E27FC236}">
-                <a16:creationId xmlns:a16="http://schemas.microsoft.com/office/drawing/2014/main" id="{DC491F4C-1831-4FB5-9649-A89782C1D054}"/>
+                <a16:creationId xmlns:a16="http://schemas.microsoft.com/office/drawing/2014/main" id="{1D28994E-C380-4FAF-A645-D0104744AB9F}"/>
               </a:ext>
             </a:extLst>
           </p:cNvPr>
@@ -5050,7 +5093,7 @@
           <p:cNvPr id="17" name="">
             <a:extLst xmlns:a="http://schemas.openxmlformats.org/drawingml/2006/main">
               <a:ext uri="{FF2B5EF4-FFF2-40B4-BE49-F238E27FC236}">
-                <a16:creationId xmlns:a16="http://schemas.microsoft.com/office/drawing/2014/main" id="{5EFE20C9-65F6-4427-BE96-345107D9D7B7}"/>
+                <a16:creationId xmlns:a16="http://schemas.microsoft.com/office/drawing/2014/main" id="{DB7081B7-6E75-4721-B68C-DB4824248E6A}"/>
               </a:ext>
             </a:extLst>
           </p:cNvPr>
@@ -5158,7 +5201,7 @@
           <p:cNvPr id="18" name="">
             <a:extLst xmlns:a="http://schemas.openxmlformats.org/drawingml/2006/main">
               <a:ext uri="{FF2B5EF4-FFF2-40B4-BE49-F238E27FC236}">
-                <a16:creationId xmlns:a16="http://schemas.microsoft.com/office/drawing/2014/main" id="{5F1C8A6B-978C-44E8-AAFF-778AC576BC6B}"/>
+                <a16:creationId xmlns:a16="http://schemas.microsoft.com/office/drawing/2014/main" id="{8DF1B4F8-A75C-4C9C-B2E8-4C02F9336B53}"/>
               </a:ext>
             </a:extLst>
           </p:cNvPr>
@@ -5215,7 +5258,7 @@
           <p:cNvPr id="19" name="">
             <a:extLst xmlns:a="http://schemas.openxmlformats.org/drawingml/2006/main">
               <a:ext uri="{FF2B5EF4-FFF2-40B4-BE49-F238E27FC236}">
-                <a16:creationId xmlns:a16="http://schemas.microsoft.com/office/drawing/2014/main" id="{16B386BC-C2E6-40D4-A878-ABC498020739}"/>
+                <a16:creationId xmlns:a16="http://schemas.microsoft.com/office/drawing/2014/main" id="{F2DE1D43-9658-413B-9DCA-D301BFC41EC5}"/>
               </a:ext>
             </a:extLst>
           </p:cNvPr>
@@ -5323,7 +5366,7 @@
           <p:cNvPr id="20" name="">
             <a:extLst xmlns:a="http://schemas.openxmlformats.org/drawingml/2006/main">
               <a:ext uri="{FF2B5EF4-FFF2-40B4-BE49-F238E27FC236}">
-                <a16:creationId xmlns:a16="http://schemas.microsoft.com/office/drawing/2014/main" id="{3482599B-A2E0-4F90-BE6B-3C04D7C06116}"/>
+                <a16:creationId xmlns:a16="http://schemas.microsoft.com/office/drawing/2014/main" id="{6D0D76AB-F32F-4C45-87A6-673F9BE48050}"/>
               </a:ext>
             </a:extLst>
           </p:cNvPr>
@@ -5380,7 +5423,7 @@
           <p:cNvPr id="21" name="">
             <a:extLst xmlns:a="http://schemas.openxmlformats.org/drawingml/2006/main">
               <a:ext uri="{FF2B5EF4-FFF2-40B4-BE49-F238E27FC236}">
-                <a16:creationId xmlns:a16="http://schemas.microsoft.com/office/drawing/2014/main" id="{29062DA1-F4E1-4EE3-8EB4-C249FB5EFB3D}"/>
+                <a16:creationId xmlns:a16="http://schemas.microsoft.com/office/drawing/2014/main" id="{43C9F774-3D84-4D4D-9BE7-AFA731A87D8B}"/>
               </a:ext>
             </a:extLst>
           </p:cNvPr>
@@ -5488,7 +5531,7 @@
           <p:cNvPr id="22" name="">
             <a:extLst xmlns:a="http://schemas.openxmlformats.org/drawingml/2006/main">
               <a:ext uri="{FF2B5EF4-FFF2-40B4-BE49-F238E27FC236}">
-                <a16:creationId xmlns:a16="http://schemas.microsoft.com/office/drawing/2014/main" id="{A78EFCB5-B8A2-4511-9C3A-82839C93F2F9}"/>
+                <a16:creationId xmlns:a16="http://schemas.microsoft.com/office/drawing/2014/main" id="{4C62EF93-627B-4E58-8228-DD58E5C15C13}"/>
               </a:ext>
             </a:extLst>
           </p:cNvPr>
@@ -5690,7 +5733,7 @@
           <p:cNvPr id="10" name="">
             <a:extLst xmlns:a="http://schemas.openxmlformats.org/drawingml/2006/main">
               <a:ext uri="{FF2B5EF4-FFF2-40B4-BE49-F238E27FC236}">
-                <a16:creationId xmlns:a16="http://schemas.microsoft.com/office/drawing/2014/main" id="{22E04BCA-5F40-4A92-88B6-65FAA5B35072}"/>
+                <a16:creationId xmlns:a16="http://schemas.microsoft.com/office/drawing/2014/main" id="{0A732C04-2D58-447E-9560-41AD063C3D92}"/>
               </a:ext>
             </a:extLst>
           </p:cNvPr>
@@ -5770,7 +5813,7 @@
           <p:cNvPr id="11" name="">
             <a:extLst xmlns:a="http://schemas.openxmlformats.org/drawingml/2006/main">
               <a:ext uri="{FF2B5EF4-FFF2-40B4-BE49-F238E27FC236}">
-                <a16:creationId xmlns:a16="http://schemas.microsoft.com/office/drawing/2014/main" id="{0066DEBC-7F59-4A05-8B16-841827B6DBD2}"/>
+                <a16:creationId xmlns:a16="http://schemas.microsoft.com/office/drawing/2014/main" id="{F9FA8C06-F17B-4E4C-873C-E8DD6C1F1B68}"/>
               </a:ext>
             </a:extLst>
           </p:cNvPr>
@@ -5827,7 +5870,7 @@
           <p:cNvPr id="12" name="">
             <a:extLst xmlns:a="http://schemas.openxmlformats.org/drawingml/2006/main">
               <a:ext uri="{FF2B5EF4-FFF2-40B4-BE49-F238E27FC236}">
-                <a16:creationId xmlns:a16="http://schemas.microsoft.com/office/drawing/2014/main" id="{1F1662BB-5A48-4AE4-869E-8EC5646187DF}"/>
+                <a16:creationId xmlns:a16="http://schemas.microsoft.com/office/drawing/2014/main" id="{EF456036-CD9B-484E-AEED-925DEADACBEB}"/>
               </a:ext>
             </a:extLst>
           </p:cNvPr>
@@ -5884,7 +5927,7 @@
           <p:cNvPr id="13" name="">
             <a:extLst xmlns:a="http://schemas.openxmlformats.org/drawingml/2006/main">
               <a:ext uri="{FF2B5EF4-FFF2-40B4-BE49-F238E27FC236}">
-                <a16:creationId xmlns:a16="http://schemas.microsoft.com/office/drawing/2014/main" id="{228CAAC8-C30F-49D6-BAA0-253CEFE99B4D}"/>
+                <a16:creationId xmlns:a16="http://schemas.microsoft.com/office/drawing/2014/main" id="{31C9801A-160A-49B1-8BBD-3D87603A0FC4}"/>
               </a:ext>
             </a:extLst>
           </p:cNvPr>
@@ -5941,7 +5984,7 @@
           <p:cNvPr id="14" name="">
             <a:extLst xmlns:a="http://schemas.openxmlformats.org/drawingml/2006/main">
               <a:ext uri="{FF2B5EF4-FFF2-40B4-BE49-F238E27FC236}">
-                <a16:creationId xmlns:a16="http://schemas.microsoft.com/office/drawing/2014/main" id="{20CD42EC-B0B8-463F-9315-7BC9A8A1F17A}"/>
+                <a16:creationId xmlns:a16="http://schemas.microsoft.com/office/drawing/2014/main" id="{566F5063-3B7C-460C-83F7-FEA6EFD31CC6}"/>
               </a:ext>
             </a:extLst>
           </p:cNvPr>
@@ -5998,7 +6041,7 @@
           <p:cNvPr id="15" name="">
             <a:extLst xmlns:a="http://schemas.openxmlformats.org/drawingml/2006/main">
               <a:ext uri="{FF2B5EF4-FFF2-40B4-BE49-F238E27FC236}">
-                <a16:creationId xmlns:a16="http://schemas.microsoft.com/office/drawing/2014/main" id="{D44E317B-8C0A-4868-958E-104DDD7D332D}"/>
+                <a16:creationId xmlns:a16="http://schemas.microsoft.com/office/drawing/2014/main" id="{DA957B4C-6185-4EA5-9626-B1B713C3C316}"/>
               </a:ext>
             </a:extLst>
           </p:cNvPr>
@@ -6200,7 +6243,7 @@
           <p:cNvPr id="10" name="">
             <a:extLst xmlns:a="http://schemas.openxmlformats.org/drawingml/2006/main">
               <a:ext uri="{FF2B5EF4-FFF2-40B4-BE49-F238E27FC236}">
-                <a16:creationId xmlns:a16="http://schemas.microsoft.com/office/drawing/2014/main" id="{12B79DF5-E495-4070-B302-AA236F1B925B}"/>
+                <a16:creationId xmlns:a16="http://schemas.microsoft.com/office/drawing/2014/main" id="{E6A71317-8045-4007-B42D-EA8D37CD446B}"/>
               </a:ext>
             </a:extLst>
           </p:cNvPr>
@@ -6257,7 +6300,7 @@
           <p:cNvPr id="11" name="">
             <a:extLst xmlns:a="http://schemas.openxmlformats.org/drawingml/2006/main">
               <a:ext uri="{FF2B5EF4-FFF2-40B4-BE49-F238E27FC236}">
-                <a16:creationId xmlns:a16="http://schemas.microsoft.com/office/drawing/2014/main" id="{F29FFE02-654B-49E9-A84A-21A4C1075C9C}"/>
+                <a16:creationId xmlns:a16="http://schemas.microsoft.com/office/drawing/2014/main" id="{A95C85BE-97ED-4868-84AC-201A7B9A9495}"/>
               </a:ext>
             </a:extLst>
           </p:cNvPr>
@@ -6287,7 +6330,7 @@
           <p:cNvPr id="12" name="">
             <a:extLst xmlns:a="http://schemas.openxmlformats.org/drawingml/2006/main">
               <a:ext uri="{FF2B5EF4-FFF2-40B4-BE49-F238E27FC236}">
-                <a16:creationId xmlns:a16="http://schemas.microsoft.com/office/drawing/2014/main" id="{93C9AE23-223E-4CB6-87DB-4BC536C377DA}"/>
+                <a16:creationId xmlns:a16="http://schemas.microsoft.com/office/drawing/2014/main" id="{606F46AD-3E93-4603-96A9-3FB1647FBDBC}"/>
               </a:ext>
             </a:extLst>
           </p:cNvPr>
@@ -6344,7 +6387,7 @@
           <p:cNvPr id="13" name="">
             <a:extLst xmlns:a="http://schemas.openxmlformats.org/drawingml/2006/main">
               <a:ext uri="{FF2B5EF4-FFF2-40B4-BE49-F238E27FC236}">
-                <a16:creationId xmlns:a16="http://schemas.microsoft.com/office/drawing/2014/main" id="{BFB9FD1E-5A9E-4B6F-97AA-E78BF799039B}"/>
+                <a16:creationId xmlns:a16="http://schemas.microsoft.com/office/drawing/2014/main" id="{D85EFC7F-3981-4DF7-B68C-B5C0BAD1B5DE}"/>
               </a:ext>
             </a:extLst>
           </p:cNvPr>
@@ -6401,7 +6444,7 @@
           <p:cNvPr id="14" name="">
             <a:extLst xmlns:a="http://schemas.openxmlformats.org/drawingml/2006/main">
               <a:ext uri="{FF2B5EF4-FFF2-40B4-BE49-F238E27FC236}">
-                <a16:creationId xmlns:a16="http://schemas.microsoft.com/office/drawing/2014/main" id="{769ECA9E-69D5-4C35-AEF3-519EBDEFC305}"/>
+                <a16:creationId xmlns:a16="http://schemas.microsoft.com/office/drawing/2014/main" id="{82969C44-C8A5-43EA-B2A7-6A9B4F956E05}"/>
               </a:ext>
             </a:extLst>
           </p:cNvPr>
@@ -6431,7 +6474,7 @@
           <p:cNvPr id="15" name="">
             <a:extLst xmlns:a="http://schemas.openxmlformats.org/drawingml/2006/main">
               <a:ext uri="{FF2B5EF4-FFF2-40B4-BE49-F238E27FC236}">
-                <a16:creationId xmlns:a16="http://schemas.microsoft.com/office/drawing/2014/main" id="{13BEC2F2-8E2A-4E42-9330-A556A02030C0}"/>
+                <a16:creationId xmlns:a16="http://schemas.microsoft.com/office/drawing/2014/main" id="{035B2DC8-17AE-4FE5-B9DD-2FF02ABE94B0}"/>
               </a:ext>
             </a:extLst>
           </p:cNvPr>
@@ -6488,7 +6531,7 @@
           <p:cNvPr id="16" name="">
             <a:extLst xmlns:a="http://schemas.openxmlformats.org/drawingml/2006/main">
               <a:ext uri="{FF2B5EF4-FFF2-40B4-BE49-F238E27FC236}">
-                <a16:creationId xmlns:a16="http://schemas.microsoft.com/office/drawing/2014/main" id="{75764950-5410-462F-A963-CDF0B90A66DD}"/>
+                <a16:creationId xmlns:a16="http://schemas.microsoft.com/office/drawing/2014/main" id="{D4AC4927-77EC-43D6-8627-DEA7A20411AE}"/>
               </a:ext>
             </a:extLst>
           </p:cNvPr>
@@ -6545,7 +6588,7 @@
           <p:cNvPr id="17" name="">
             <a:extLst xmlns:a="http://schemas.openxmlformats.org/drawingml/2006/main">
               <a:ext uri="{FF2B5EF4-FFF2-40B4-BE49-F238E27FC236}">
-                <a16:creationId xmlns:a16="http://schemas.microsoft.com/office/drawing/2014/main" id="{2D539192-6BAA-4A5D-992E-BDB9799573B8}"/>
+                <a16:creationId xmlns:a16="http://schemas.microsoft.com/office/drawing/2014/main" id="{27FA2032-D8C7-4AA8-8CB7-26D813B93388}"/>
               </a:ext>
             </a:extLst>
           </p:cNvPr>
@@ -6575,7 +6618,7 @@
           <p:cNvPr id="18" name="">
             <a:extLst xmlns:a="http://schemas.openxmlformats.org/drawingml/2006/main">
               <a:ext uri="{FF2B5EF4-FFF2-40B4-BE49-F238E27FC236}">
-                <a16:creationId xmlns:a16="http://schemas.microsoft.com/office/drawing/2014/main" id="{1FB37406-5F45-4899-AAB0-D192E08BE381}"/>
+                <a16:creationId xmlns:a16="http://schemas.microsoft.com/office/drawing/2014/main" id="{D26A9AE6-D6BA-4D73-B88F-579449665E40}"/>
               </a:ext>
             </a:extLst>
           </p:cNvPr>
@@ -6632,7 +6675,7 @@
           <p:cNvPr id="19" name="">
             <a:extLst xmlns:a="http://schemas.openxmlformats.org/drawingml/2006/main">
               <a:ext uri="{FF2B5EF4-FFF2-40B4-BE49-F238E27FC236}">
-                <a16:creationId xmlns:a16="http://schemas.microsoft.com/office/drawing/2014/main" id="{B858DFE2-A6F2-44E1-928A-46CC38DED476}"/>
+                <a16:creationId xmlns:a16="http://schemas.microsoft.com/office/drawing/2014/main" id="{8F028823-1298-4A56-B230-7EAB6E6C7982}"/>
               </a:ext>
             </a:extLst>
           </p:cNvPr>
@@ -6689,7 +6732,7 @@
           <p:cNvPr id="20" name="">
             <a:extLst xmlns:a="http://schemas.openxmlformats.org/drawingml/2006/main">
               <a:ext uri="{FF2B5EF4-FFF2-40B4-BE49-F238E27FC236}">
-                <a16:creationId xmlns:a16="http://schemas.microsoft.com/office/drawing/2014/main" id="{998EEAED-9069-46D7-A646-6E99D1C0FAEF}"/>
+                <a16:creationId xmlns:a16="http://schemas.microsoft.com/office/drawing/2014/main" id="{3E76ED54-FA54-40F9-8CA3-261ED95C4C1A}"/>
               </a:ext>
             </a:extLst>
           </p:cNvPr>
@@ -6719,7 +6762,7 @@
           <p:cNvPr id="21" name="">
             <a:extLst xmlns:a="http://schemas.openxmlformats.org/drawingml/2006/main">
               <a:ext uri="{FF2B5EF4-FFF2-40B4-BE49-F238E27FC236}">
-                <a16:creationId xmlns:a16="http://schemas.microsoft.com/office/drawing/2014/main" id="{DB6BE832-C622-41D7-96F1-914495FDE011}"/>
+                <a16:creationId xmlns:a16="http://schemas.microsoft.com/office/drawing/2014/main" id="{F0FC325E-6AFC-4736-8B08-71B8B43781B6}"/>
               </a:ext>
             </a:extLst>
           </p:cNvPr>
@@ -6776,7 +6819,7 @@
           <p:cNvPr id="22" name="">
             <a:extLst xmlns:a="http://schemas.openxmlformats.org/drawingml/2006/main">
               <a:ext uri="{FF2B5EF4-FFF2-40B4-BE49-F238E27FC236}">
-                <a16:creationId xmlns:a16="http://schemas.microsoft.com/office/drawing/2014/main" id="{BE3F47C8-8D24-4C26-B28A-906161EB9285}"/>
+                <a16:creationId xmlns:a16="http://schemas.microsoft.com/office/drawing/2014/main" id="{D5FF924E-EE68-41EE-A673-C5AC1582C807}"/>
               </a:ext>
             </a:extLst>
           </p:cNvPr>
@@ -6908,7 +6951,7 @@
           <p:cNvPr id="26" name="">
             <a:extLst xmlns:a="http://schemas.openxmlformats.org/drawingml/2006/main">
               <a:ext uri="{FF2B5EF4-FFF2-40B4-BE49-F238E27FC236}">
-                <a16:creationId xmlns:a16="http://schemas.microsoft.com/office/drawing/2014/main" id="{5CE3F4FD-04A7-4FB8-9149-5D396F55A464}"/>
+                <a16:creationId xmlns:a16="http://schemas.microsoft.com/office/drawing/2014/main" id="{3687BE8D-AFAA-48BC-9A32-4146B8961D32}"/>
               </a:ext>
             </a:extLst>
           </p:cNvPr>
@@ -7110,7 +7153,7 @@
           <p:cNvPr id="9" name="">
             <a:extLst xmlns:a="http://schemas.openxmlformats.org/drawingml/2006/main">
               <a:ext uri="{FF2B5EF4-FFF2-40B4-BE49-F238E27FC236}">
-                <a16:creationId xmlns:a16="http://schemas.microsoft.com/office/drawing/2014/main" id="{A7933A88-B575-4698-9CB1-9B491BA01FAC}"/>
+                <a16:creationId xmlns:a16="http://schemas.microsoft.com/office/drawing/2014/main" id="{009A7D96-C94B-47F9-BC68-3C5721AA5BD8}"/>
               </a:ext>
             </a:extLst>
           </p:cNvPr>
@@ -7167,7 +7210,7 @@
           <p:cNvPr id="10" name="">
             <a:extLst xmlns:a="http://schemas.openxmlformats.org/drawingml/2006/main">
               <a:ext uri="{FF2B5EF4-FFF2-40B4-BE49-F238E27FC236}">
-                <a16:creationId xmlns:a16="http://schemas.microsoft.com/office/drawing/2014/main" id="{096793DA-363A-490F-B2D1-63C96CC39A7A}"/>
+                <a16:creationId xmlns:a16="http://schemas.microsoft.com/office/drawing/2014/main" id="{AE990C9C-7940-47A8-8006-EEEEE553175B}"/>
               </a:ext>
             </a:extLst>
           </p:cNvPr>
@@ -7224,7 +7267,7 @@
           <p:cNvPr id="11" name="">
             <a:extLst xmlns:a="http://schemas.openxmlformats.org/drawingml/2006/main">
               <a:ext uri="{FF2B5EF4-FFF2-40B4-BE49-F238E27FC236}">
-                <a16:creationId xmlns:a16="http://schemas.microsoft.com/office/drawing/2014/main" id="{8B274214-EF3D-4CE7-87FC-05279A1BF1D9}"/>
+                <a16:creationId xmlns:a16="http://schemas.microsoft.com/office/drawing/2014/main" id="{C28F98F5-3944-4330-BEE9-79AAE1CF7E2F}"/>
               </a:ext>
             </a:extLst>
           </p:cNvPr>
@@ -7304,7 +7347,7 @@
           <p:cNvPr id="12" name="">
             <a:extLst xmlns:a="http://schemas.openxmlformats.org/drawingml/2006/main">
               <a:ext uri="{FF2B5EF4-FFF2-40B4-BE49-F238E27FC236}">
-                <a16:creationId xmlns:a16="http://schemas.microsoft.com/office/drawing/2014/main" id="{151586B8-D22D-48F7-A74B-84AD063B06A3}"/>
+                <a16:creationId xmlns:a16="http://schemas.microsoft.com/office/drawing/2014/main" id="{6C7729E3-F53A-435A-AF8A-D5A80C07CF9B}"/>
               </a:ext>
             </a:extLst>
           </p:cNvPr>
@@ -7361,7 +7404,7 @@
           <p:cNvPr id="13" name="">
             <a:extLst xmlns:a="http://schemas.openxmlformats.org/drawingml/2006/main">
               <a:ext uri="{FF2B5EF4-FFF2-40B4-BE49-F238E27FC236}">
-                <a16:creationId xmlns:a16="http://schemas.microsoft.com/office/drawing/2014/main" id="{C7048703-DCB9-4A75-9AC3-DB4E13447077}"/>
+                <a16:creationId xmlns:a16="http://schemas.microsoft.com/office/drawing/2014/main" id="{F828DF59-B05D-4A92-B6DC-1503CAD1BD50}"/>
               </a:ext>
             </a:extLst>
           </p:cNvPr>
@@ -7418,7 +7461,7 @@
           <p:cNvPr id="14" name="">
             <a:extLst xmlns:a="http://schemas.openxmlformats.org/drawingml/2006/main">
               <a:ext uri="{FF2B5EF4-FFF2-40B4-BE49-F238E27FC236}">
-                <a16:creationId xmlns:a16="http://schemas.microsoft.com/office/drawing/2014/main" id="{83B2995C-8CD3-4A9A-B724-B42130640933}"/>
+                <a16:creationId xmlns:a16="http://schemas.microsoft.com/office/drawing/2014/main" id="{1A5DE226-2768-4320-93BE-E6DD0BDA1F4E}"/>
               </a:ext>
             </a:extLst>
           </p:cNvPr>
@@ -7498,7 +7541,7 @@
           <p:cNvPr id="15" name="">
             <a:extLst xmlns:a="http://schemas.openxmlformats.org/drawingml/2006/main">
               <a:ext uri="{FF2B5EF4-FFF2-40B4-BE49-F238E27FC236}">
-                <a16:creationId xmlns:a16="http://schemas.microsoft.com/office/drawing/2014/main" id="{3BB50B44-3DD3-41F1-BC99-FF10CE706ACC}"/>
+                <a16:creationId xmlns:a16="http://schemas.microsoft.com/office/drawing/2014/main" id="{35B7C575-5395-4BAC-A6BE-217861D02856}"/>
               </a:ext>
             </a:extLst>
           </p:cNvPr>
@@ -7700,7 +7743,7 @@
           <p:cNvPr id="16" name="">
             <a:extLst xmlns:a="http://schemas.openxmlformats.org/drawingml/2006/main">
               <a:ext uri="{FF2B5EF4-FFF2-40B4-BE49-F238E27FC236}">
-                <a16:creationId xmlns:a16="http://schemas.microsoft.com/office/drawing/2014/main" id="{E65B596A-51FA-4FC3-AD81-B8F2808BE793}"/>
+                <a16:creationId xmlns:a16="http://schemas.microsoft.com/office/drawing/2014/main" id="{B8BC6FAE-83E9-4AB9-9BD8-F14D784926E3}"/>
               </a:ext>
             </a:extLst>
           </p:cNvPr>
@@ -7757,7 +7800,7 @@
           <p:cNvPr id="17" name="">
             <a:extLst xmlns:a="http://schemas.openxmlformats.org/drawingml/2006/main">
               <a:ext uri="{FF2B5EF4-FFF2-40B4-BE49-F238E27FC236}">
-                <a16:creationId xmlns:a16="http://schemas.microsoft.com/office/drawing/2014/main" id="{01475F89-E6AB-43C2-91D0-059042795AB9}"/>
+                <a16:creationId xmlns:a16="http://schemas.microsoft.com/office/drawing/2014/main" id="{3AADFA6D-C693-4EA0-A02E-C4CE2BD3A107}"/>
               </a:ext>
             </a:extLst>
           </p:cNvPr>
@@ -7814,7 +7857,7 @@
           <p:cNvPr id="18" name="">
             <a:extLst xmlns:a="http://schemas.openxmlformats.org/drawingml/2006/main">
               <a:ext uri="{FF2B5EF4-FFF2-40B4-BE49-F238E27FC236}">
-                <a16:creationId xmlns:a16="http://schemas.microsoft.com/office/drawing/2014/main" id="{78FE37B4-1BBA-4908-8E8B-D47D009337F4}"/>
+                <a16:creationId xmlns:a16="http://schemas.microsoft.com/office/drawing/2014/main" id="{4EAE18D1-017A-4CD4-8BA6-B3A61BD369B2}"/>
               </a:ext>
             </a:extLst>
           </p:cNvPr>
@@ -7871,7 +7914,7 @@
           <p:cNvPr id="19" name="">
             <a:extLst xmlns:a="http://schemas.openxmlformats.org/drawingml/2006/main">
               <a:ext uri="{FF2B5EF4-FFF2-40B4-BE49-F238E27FC236}">
-                <a16:creationId xmlns:a16="http://schemas.microsoft.com/office/drawing/2014/main" id="{C28C51B3-09B0-46AE-9EDB-0F8F1023FF06}"/>
+                <a16:creationId xmlns:a16="http://schemas.microsoft.com/office/drawing/2014/main" id="{9E4E1165-98BD-4562-968C-B3000B8A4843}"/>
               </a:ext>
             </a:extLst>
           </p:cNvPr>
@@ -7928,7 +7971,7 @@
           <p:cNvPr id="20" name="">
             <a:extLst xmlns:a="http://schemas.openxmlformats.org/drawingml/2006/main">
               <a:ext uri="{FF2B5EF4-FFF2-40B4-BE49-F238E27FC236}">
-                <a16:creationId xmlns:a16="http://schemas.microsoft.com/office/drawing/2014/main" id="{EF8A1040-A018-4F33-B13C-E3086EBEBCA4}"/>
+                <a16:creationId xmlns:a16="http://schemas.microsoft.com/office/drawing/2014/main" id="{AAF46055-2B5F-4DF1-9219-181C383810CC}"/>
               </a:ext>
             </a:extLst>
           </p:cNvPr>
@@ -8008,7 +8051,7 @@
           <p:cNvPr id="21" name="">
             <a:extLst xmlns:a="http://schemas.openxmlformats.org/drawingml/2006/main">
               <a:ext uri="{FF2B5EF4-FFF2-40B4-BE49-F238E27FC236}">
-                <a16:creationId xmlns:a16="http://schemas.microsoft.com/office/drawing/2014/main" id="{80393DE7-3118-40BE-8712-7A4ED7948D32}"/>
+                <a16:creationId xmlns:a16="http://schemas.microsoft.com/office/drawing/2014/main" id="{61F3D9E3-5F73-451A-9C89-62CCA55D0836}"/>
               </a:ext>
             </a:extLst>
           </p:cNvPr>
@@ -8088,7 +8131,7 @@
           <p:cNvPr id="22" name="">
             <a:extLst xmlns:a="http://schemas.openxmlformats.org/drawingml/2006/main">
               <a:ext uri="{FF2B5EF4-FFF2-40B4-BE49-F238E27FC236}">
-                <a16:creationId xmlns:a16="http://schemas.microsoft.com/office/drawing/2014/main" id="{DB84004E-82B0-4C23-ACEE-E10C05ED6DAE}"/>
+                <a16:creationId xmlns:a16="http://schemas.microsoft.com/office/drawing/2014/main" id="{5D1D3AB7-89B9-4F88-828A-3CE1607A506D}"/>
               </a:ext>
             </a:extLst>
           </p:cNvPr>
@@ -8290,7 +8333,7 @@
           <p:cNvPr id="9" name="">
             <a:extLst xmlns:a="http://schemas.openxmlformats.org/drawingml/2006/main">
               <a:ext uri="{FF2B5EF4-FFF2-40B4-BE49-F238E27FC236}">
-                <a16:creationId xmlns:a16="http://schemas.microsoft.com/office/drawing/2014/main" id="{EA7A2003-11F8-4B4D-A9F2-2E20030B0EDC}"/>
+                <a16:creationId xmlns:a16="http://schemas.microsoft.com/office/drawing/2014/main" id="{A107B207-AAD2-454C-ABAE-137CEE2E8225}"/>
               </a:ext>
             </a:extLst>
           </p:cNvPr>
@@ -8354,7 +8397,7 @@
         </p:xfrm>
         <a:graphic xmlns:a="http://schemas.openxmlformats.org/drawingml/2006/main">
           <a:graphicData uri="http://schemas.openxmlformats.org/drawingml/2006/chart">
-            <c:chart xmlns:r="http://schemas.openxmlformats.org/officeDocument/2006/relationships" xmlns:c="http://schemas.openxmlformats.org/drawingml/2006/chart" r:id="R8062a601069e46f0"/>
+            <c:chart xmlns:r="http://schemas.openxmlformats.org/officeDocument/2006/relationships" xmlns:c="http://schemas.openxmlformats.org/drawingml/2006/chart" r:id="R987c10b1c828440a"/>
           </a:graphicData>
         </a:graphic>
       </p:graphicFrame>
@@ -8363,7 +8406,7 @@
           <p:cNvPr id="11" name="">
             <a:extLst xmlns:a="http://schemas.openxmlformats.org/drawingml/2006/main">
               <a:ext uri="{FF2B5EF4-FFF2-40B4-BE49-F238E27FC236}">
-                <a16:creationId xmlns:a16="http://schemas.microsoft.com/office/drawing/2014/main" id="{51FF5DF6-5142-45A5-9A77-77FD813AA6A7}"/>
+                <a16:creationId xmlns:a16="http://schemas.microsoft.com/office/drawing/2014/main" id="{DCE79339-7193-4694-B075-B29B8D49509A}"/>
               </a:ext>
             </a:extLst>
           </p:cNvPr>
@@ -8427,7 +8470,7 @@
         </p:xfrm>
         <a:graphic xmlns:a="http://schemas.openxmlformats.org/drawingml/2006/main">
           <a:graphicData uri="http://schemas.openxmlformats.org/drawingml/2006/chart">
-            <c:chart xmlns:r="http://schemas.openxmlformats.org/officeDocument/2006/relationships" xmlns:c="http://schemas.openxmlformats.org/drawingml/2006/chart" r:id="Rcc505643e9444667"/>
+            <c:chart xmlns:r="http://schemas.openxmlformats.org/officeDocument/2006/relationships" xmlns:c="http://schemas.openxmlformats.org/drawingml/2006/chart" r:id="Rfdf8f35ef5404a48"/>
           </a:graphicData>
         </a:graphic>
       </p:graphicFrame>
@@ -8436,7 +8479,7 @@
           <p:cNvPr id="13" name="">
             <a:extLst xmlns:a="http://schemas.openxmlformats.org/drawingml/2006/main">
               <a:ext uri="{FF2B5EF4-FFF2-40B4-BE49-F238E27FC236}">
-                <a16:creationId xmlns:a16="http://schemas.microsoft.com/office/drawing/2014/main" id="{F56CA11A-A1CB-4DF7-A64D-D64887D8B849}"/>
+                <a16:creationId xmlns:a16="http://schemas.microsoft.com/office/drawing/2014/main" id="{67CB6977-3E76-448F-92C2-86FFDCA14F7E}"/>
               </a:ext>
             </a:extLst>
           </p:cNvPr>
@@ -8493,7 +8536,7 @@
           <p:cNvPr id="14" name="">
             <a:extLst xmlns:a="http://schemas.openxmlformats.org/drawingml/2006/main">
               <a:ext uri="{FF2B5EF4-FFF2-40B4-BE49-F238E27FC236}">
-                <a16:creationId xmlns:a16="http://schemas.microsoft.com/office/drawing/2014/main" id="{BF859D8E-4CFA-40BC-9DBC-C084999409F7}"/>
+                <a16:creationId xmlns:a16="http://schemas.microsoft.com/office/drawing/2014/main" id="{DAD5C3F5-B527-48FB-B3F2-DA3CAA51F547}"/>
               </a:ext>
             </a:extLst>
           </p:cNvPr>
@@ -8550,7 +8593,7 @@
           <p:cNvPr id="15" name="">
             <a:extLst xmlns:a="http://schemas.openxmlformats.org/drawingml/2006/main">
               <a:ext uri="{FF2B5EF4-FFF2-40B4-BE49-F238E27FC236}">
-                <a16:creationId xmlns:a16="http://schemas.microsoft.com/office/drawing/2014/main" id="{2AB9924E-84AE-4F51-B888-3451C8CF62CD}"/>
+                <a16:creationId xmlns:a16="http://schemas.microsoft.com/office/drawing/2014/main" id="{238B3BC5-AFA4-491F-867C-10C7E070647B}"/>
               </a:ext>
             </a:extLst>
           </p:cNvPr>
@@ -8630,7 +8673,7 @@
           <p:cNvPr id="16" name="">
             <a:extLst xmlns:a="http://schemas.openxmlformats.org/drawingml/2006/main">
               <a:ext uri="{FF2B5EF4-FFF2-40B4-BE49-F238E27FC236}">
-                <a16:creationId xmlns:a16="http://schemas.microsoft.com/office/drawing/2014/main" id="{B9D51DD9-1DC1-4DB4-B62B-28A9348F7F2E}"/>
+                <a16:creationId xmlns:a16="http://schemas.microsoft.com/office/drawing/2014/main" id="{C02BFDD9-F4E5-44A8-97D3-8263C8132A9E}"/>
               </a:ext>
             </a:extLst>
           </p:cNvPr>
@@ -8733,7 +8776,7 @@
           <p:cNvPr id="17" name="">
             <a:extLst xmlns:a="http://schemas.openxmlformats.org/drawingml/2006/main">
               <a:ext uri="{FF2B5EF4-FFF2-40B4-BE49-F238E27FC236}">
-                <a16:creationId xmlns:a16="http://schemas.microsoft.com/office/drawing/2014/main" id="{368EB9D8-BE89-4FB6-84AA-AD61550D6056}"/>
+                <a16:creationId xmlns:a16="http://schemas.microsoft.com/office/drawing/2014/main" id="{306E1FE8-DDB4-40AB-BF3F-4FC3BAE75AE1}"/>
               </a:ext>
             </a:extLst>
           </p:cNvPr>
@@ -8939,7 +8982,7 @@
           <p:nvPr/>
         </p:nvPicPr>
         <p:blipFill>
-          <a:blip xmlns:r="http://schemas.openxmlformats.org/officeDocument/2006/relationships" xmlns:a="http://schemas.openxmlformats.org/drawingml/2006/main" r:embed="R969b1f90c25d49d6"/>
+          <a:blip xmlns:r="http://schemas.openxmlformats.org/officeDocument/2006/relationships" xmlns:a="http://schemas.openxmlformats.org/drawingml/2006/main" r:embed="R72b517264dda43ef"/>
           <a:stretch xmlns:a="http://schemas.openxmlformats.org/drawingml/2006/main"/>
         </p:blipFill>
         <p:spPr>
@@ -8957,7 +9000,7 @@
           <p:cNvPr id="11" name="">
             <a:extLst xmlns:a="http://schemas.openxmlformats.org/drawingml/2006/main">
               <a:ext uri="{FF2B5EF4-FFF2-40B4-BE49-F238E27FC236}">
-                <a16:creationId xmlns:a16="http://schemas.microsoft.com/office/drawing/2014/main" id="{AF2A2188-1FF4-47AB-8CA4-F8ABC65AE22A}"/>
+                <a16:creationId xmlns:a16="http://schemas.microsoft.com/office/drawing/2014/main" id="{A53DF54B-BA76-4FA8-A16F-C029B0D448B4}"/>
               </a:ext>
             </a:extLst>
           </p:cNvPr>
@@ -9014,7 +9057,7 @@
           <p:cNvPr id="12" name="">
             <a:extLst xmlns:a="http://schemas.openxmlformats.org/drawingml/2006/main">
               <a:ext uri="{FF2B5EF4-FFF2-40B4-BE49-F238E27FC236}">
-                <a16:creationId xmlns:a16="http://schemas.microsoft.com/office/drawing/2014/main" id="{5EC73A61-2E34-4DA6-9E12-B378CE8EBE80}"/>
+                <a16:creationId xmlns:a16="http://schemas.microsoft.com/office/drawing/2014/main" id="{5BBBA872-17BC-4A2D-886B-A62118915E1C}"/>
               </a:ext>
             </a:extLst>
           </p:cNvPr>
@@ -9071,7 +9114,7 @@
           <p:cNvPr id="13" name="">
             <a:extLst xmlns:a="http://schemas.openxmlformats.org/drawingml/2006/main">
               <a:ext uri="{FF2B5EF4-FFF2-40B4-BE49-F238E27FC236}">
-                <a16:creationId xmlns:a16="http://schemas.microsoft.com/office/drawing/2014/main" id="{00AE987F-D56B-4F44-BEFB-8F5EBAAA2BD1}"/>
+                <a16:creationId xmlns:a16="http://schemas.microsoft.com/office/drawing/2014/main" id="{9C3A43A4-FFE0-4917-87F1-EEB5CD6948A2}"/>
               </a:ext>
             </a:extLst>
           </p:cNvPr>
@@ -9128,7 +9171,7 @@
           <p:cNvPr id="14" name="">
             <a:extLst xmlns:a="http://schemas.openxmlformats.org/drawingml/2006/main">
               <a:ext uri="{FF2B5EF4-FFF2-40B4-BE49-F238E27FC236}">
-                <a16:creationId xmlns:a16="http://schemas.microsoft.com/office/drawing/2014/main" id="{1DD6EE1B-B969-4A32-A94D-85F1D567B681}"/>
+                <a16:creationId xmlns:a16="http://schemas.microsoft.com/office/drawing/2014/main" id="{0C8C2FF5-9420-447D-A6EC-10E71F3301F4}"/>
               </a:ext>
             </a:extLst>
           </p:cNvPr>
@@ -9185,7 +9228,7 @@
           <p:cNvPr id="15" name="">
             <a:extLst xmlns:a="http://schemas.openxmlformats.org/drawingml/2006/main">
               <a:ext uri="{FF2B5EF4-FFF2-40B4-BE49-F238E27FC236}">
-                <a16:creationId xmlns:a16="http://schemas.microsoft.com/office/drawing/2014/main" id="{DBD389E1-ADD8-4767-85B0-E26EE90510B9}"/>
+                <a16:creationId xmlns:a16="http://schemas.microsoft.com/office/drawing/2014/main" id="{24D46066-5C88-4F1E-8247-0306B27BE00E}"/>
               </a:ext>
             </a:extLst>
           </p:cNvPr>
@@ -9242,7 +9285,7 @@
           <p:cNvPr id="16" name="">
             <a:extLst xmlns:a="http://schemas.openxmlformats.org/drawingml/2006/main">
               <a:ext uri="{FF2B5EF4-FFF2-40B4-BE49-F238E27FC236}">
-                <a16:creationId xmlns:a16="http://schemas.microsoft.com/office/drawing/2014/main" id="{D450A622-5997-4B20-A0FC-A710ABD1A781}"/>
+                <a16:creationId xmlns:a16="http://schemas.microsoft.com/office/drawing/2014/main" id="{E0ED39E6-6022-4251-ACC2-6913E1E780FF}"/>
               </a:ext>
             </a:extLst>
           </p:cNvPr>
@@ -9299,7 +9342,7 @@
           <p:cNvPr id="17" name="">
             <a:extLst xmlns:a="http://schemas.openxmlformats.org/drawingml/2006/main">
               <a:ext uri="{FF2B5EF4-FFF2-40B4-BE49-F238E27FC236}">
-                <a16:creationId xmlns:a16="http://schemas.microsoft.com/office/drawing/2014/main" id="{DB119092-136C-42CF-9821-1E302497F148}"/>
+                <a16:creationId xmlns:a16="http://schemas.microsoft.com/office/drawing/2014/main" id="{574A7A59-78CD-418A-8AE3-B34EE8C510EB}"/>
               </a:ext>
             </a:extLst>
           </p:cNvPr>
@@ -9501,7 +9544,7 @@
           <p:cNvPr id="9" name="">
             <a:extLst xmlns:a="http://schemas.openxmlformats.org/drawingml/2006/main">
               <a:ext uri="{FF2B5EF4-FFF2-40B4-BE49-F238E27FC236}">
-                <a16:creationId xmlns:a16="http://schemas.microsoft.com/office/drawing/2014/main" id="{ABD1A03B-B680-40E5-9275-382FDE1AC739}"/>
+                <a16:creationId xmlns:a16="http://schemas.microsoft.com/office/drawing/2014/main" id="{513AB02D-0B94-4882-A35F-FA8598B08767}"/>
               </a:ext>
             </a:extLst>
           </p:cNvPr>
@@ -9565,7 +9608,7 @@
         </p:xfrm>
         <a:graphic xmlns:a="http://schemas.openxmlformats.org/drawingml/2006/main">
           <a:graphicData uri="http://schemas.openxmlformats.org/drawingml/2006/chart">
-            <c:chart xmlns:r="http://schemas.openxmlformats.org/officeDocument/2006/relationships" xmlns:c="http://schemas.openxmlformats.org/drawingml/2006/chart" r:id="Rf9c4a06f65114eac"/>
+            <c:chart xmlns:r="http://schemas.openxmlformats.org/officeDocument/2006/relationships" xmlns:c="http://schemas.openxmlformats.org/drawingml/2006/chart" r:id="Rfea1d8115c5749e7"/>
           </a:graphicData>
         </a:graphic>
       </p:graphicFrame>
@@ -9574,7 +9617,7 @@
           <p:cNvPr id="11" name="">
             <a:extLst xmlns:a="http://schemas.openxmlformats.org/drawingml/2006/main">
               <a:ext uri="{FF2B5EF4-FFF2-40B4-BE49-F238E27FC236}">
-                <a16:creationId xmlns:a16="http://schemas.microsoft.com/office/drawing/2014/main" id="{EFBD4BE8-927B-48C7-9E3F-9D69D51AFDED}"/>
+                <a16:creationId xmlns:a16="http://schemas.microsoft.com/office/drawing/2014/main" id="{92E31E48-832F-4230-9D8A-F7BE4373D679}"/>
               </a:ext>
             </a:extLst>
           </p:cNvPr>
@@ -9631,7 +9674,7 @@
           <p:cNvPr id="12" name="">
             <a:extLst xmlns:a="http://schemas.openxmlformats.org/drawingml/2006/main">
               <a:ext uri="{FF2B5EF4-FFF2-40B4-BE49-F238E27FC236}">
-                <a16:creationId xmlns:a16="http://schemas.microsoft.com/office/drawing/2014/main" id="{166FE6A4-8A35-40F0-BFE0-100EAB646D45}"/>
+                <a16:creationId xmlns:a16="http://schemas.microsoft.com/office/drawing/2014/main" id="{84B560FF-B22A-42C6-AAF0-3C643809690C}"/>
               </a:ext>
             </a:extLst>
           </p:cNvPr>
@@ -9711,7 +9754,7 @@
           <p:cNvPr id="13" name="">
             <a:extLst xmlns:a="http://schemas.openxmlformats.org/drawingml/2006/main">
               <a:ext uri="{FF2B5EF4-FFF2-40B4-BE49-F238E27FC236}">
-                <a16:creationId xmlns:a16="http://schemas.microsoft.com/office/drawing/2014/main" id="{FB09BDD8-3BF4-4CB8-ACC9-4B5EDEFCBAEF}"/>
+                <a16:creationId xmlns:a16="http://schemas.microsoft.com/office/drawing/2014/main" id="{1EFF133B-0D8F-440E-A9A6-4DD0A1D16F6C}"/>
               </a:ext>
             </a:extLst>
           </p:cNvPr>
@@ -9791,7 +9834,7 @@
           <p:cNvPr id="14" name="">
             <a:extLst xmlns:a="http://schemas.openxmlformats.org/drawingml/2006/main">
               <a:ext uri="{FF2B5EF4-FFF2-40B4-BE49-F238E27FC236}">
-                <a16:creationId xmlns:a16="http://schemas.microsoft.com/office/drawing/2014/main" id="{2E6E2D44-519C-432B-AD85-12C0B0D010F9}"/>
+                <a16:creationId xmlns:a16="http://schemas.microsoft.com/office/drawing/2014/main" id="{C7D01F09-3660-4721-9A7F-74352FCEE2BE}"/>
               </a:ext>
             </a:extLst>
           </p:cNvPr>
@@ -9925,7 +9968,7 @@
                 <a:ea typeface="Arial"/>
                 <a:cs typeface="Arial"/>
               </a:rPr>
-              <a:t>More detections, more false alarms</a:t>
+              <a:t>Archived weather inputs</a:t>
             </a:r>
           </a:p>
         </p:txBody>
@@ -9993,7 +10036,7 @@
           <p:cNvPr id="10" name="">
             <a:extLst xmlns:a="http://schemas.openxmlformats.org/drawingml/2006/main">
               <a:ext uri="{FF2B5EF4-FFF2-40B4-BE49-F238E27FC236}">
-                <a16:creationId xmlns:a16="http://schemas.microsoft.com/office/drawing/2014/main" id="{354EBE14-DF47-4555-9D5A-CFBF3A45AFA6}"/>
+                <a16:creationId xmlns:a16="http://schemas.microsoft.com/office/drawing/2014/main" id="{760CA6A7-2B26-4AF4-A11C-CC8BA03FC848}"/>
               </a:ext>
             </a:extLst>
           </p:cNvPr>
@@ -10005,7 +10048,7 @@
         <p:spPr>
           <a:xfrm xmlns:a="http://schemas.openxmlformats.org/drawingml/2006/main">
             <a:off x="647700" y="1352550"/>
-            <a:ext cx="10477500" cy="495300"/>
+            <a:ext cx="10763250" cy="495300"/>
           </a:xfrm>
           <a:prstGeom xmlns:a="http://schemas.openxmlformats.org/drawingml/2006/main" prst="rect">
             <a:avLst/>
@@ -10040,33 +10083,449 @@
                 <a:ea typeface="Arial"/>
                 <a:cs typeface="Arial"/>
               </a:rPr>
-              <a:t>Research comparison, all 3,567 test hours</a:t>
+              <a:t>Retrospective comparison, the same 3,567 test hours</a:t>
             </a:r>
           </a:p>
         </p:txBody>
       </p:sp>
       <p:graphicFrame>
         <p:nvGraphicFramePr>
-          <p:cNvPr id="19" name="Chart"/>
+          <p:cNvPr id="18" name="Chart"/>
           <p:cNvGraphicFramePr/>
           <p:nvPr/>
         </p:nvGraphicFramePr>
         <p:xfrm>
-          <a:off xmlns:a="http://schemas.openxmlformats.org/drawingml/2006/main" x="571500" y="2085975"/>
-          <a:ext xmlns:a="http://schemas.openxmlformats.org/drawingml/2006/main" cx="7572375" cy="3476625"/>
+          <a:off xmlns:a="http://schemas.openxmlformats.org/drawingml/2006/main" x="571500" y="2162175"/>
+          <a:ext xmlns:a="http://schemas.openxmlformats.org/drawingml/2006/main" cx="4667250" cy="3143250"/>
         </p:xfrm>
         <a:graphic xmlns:a="http://schemas.openxmlformats.org/drawingml/2006/main">
           <a:graphicData uri="http://schemas.openxmlformats.org/drawingml/2006/chart">
-            <c:chart xmlns:r="http://schemas.openxmlformats.org/officeDocument/2006/relationships" xmlns:c="http://schemas.openxmlformats.org/drawingml/2006/chart" r:id="R584b516242374d4a"/>
+            <c:chart xmlns:r="http://schemas.openxmlformats.org/officeDocument/2006/relationships" xmlns:c="http://schemas.openxmlformats.org/drawingml/2006/chart" r:id="R4f709f97844f4c63"/>
           </a:graphicData>
         </a:graphic>
       </p:graphicFrame>
-      <p:sp>
-        <p:nvSpPr>
-          <p:cNvPr id="12" name="">
+      <p:graphicFrame>
+        <p:nvGraphicFramePr>
+          <p:cNvPr id="19" name=""/>
+          <p:cNvGraphicFramePr/>
+          <p:nvPr/>
+        </p:nvGraphicFramePr>
+        <p:xfrm>
+          <a:off xmlns:a="http://schemas.openxmlformats.org/drawingml/2006/main" x="5562600" y="2305050"/>
+          <a:ext xmlns:a="http://schemas.openxmlformats.org/drawingml/2006/main" cx="5972175" cy="2514600"/>
+        </p:xfrm>
+        <a:graphic xmlns:a="http://schemas.openxmlformats.org/drawingml/2006/main">
+          <a:graphicData uri="http://schemas.openxmlformats.org/drawingml/2006/table">
+            <a:tbl>
+              <a:tblPr firstRow="0" bandRow="0"/>
+              <a:tblGrid>
+                <a:gridCol w="1952625"/>
+                <a:gridCol w="1438275"/>
+                <a:gridCol w="1314450"/>
+                <a:gridCol w="1266825"/>
+              </a:tblGrid>
+              <a:tr h="628650">
+                <a:tc>
+                  <a:txBody>
+                    <a:bodyPr/>
+                    <a:lstStyle/>
+                    <a:p>
+                      <a:r>
+                        <a:rPr sz="1800" b="1">
+                          <a:solidFill>
+                            <a:srgbClr val="626262"/>
+                          </a:solidFill>
+                          <a:latin typeface="Arial"/>
+                          <a:ea typeface="Arial"/>
+                          <a:cs typeface="Arial"/>
+                        </a:rPr>
+                        <a:t/>
+                      </a:r>
+                    </a:p>
+                  </a:txBody>
+                  <a:tcPr marL="91440" marR="91440" marT="45720" marB="45720">
+                    <a:solidFill>
+                      <a:srgbClr val="FAFAFA"/>
+                    </a:solidFill>
+                  </a:tcPr>
+                </a:tc>
+                <a:tc>
+                  <a:txBody>
+                    <a:bodyPr/>
+                    <a:lstStyle/>
+                    <a:p>
+                      <a:r>
+                        <a:rPr sz="1800" b="1">
+                          <a:solidFill>
+                            <a:srgbClr val="626262"/>
+                          </a:solidFill>
+                          <a:latin typeface="Arial"/>
+                          <a:ea typeface="Arial"/>
+                          <a:cs typeface="Arial"/>
+                        </a:rPr>
+                        <a:t>Precision</a:t>
+                      </a:r>
+                    </a:p>
+                  </a:txBody>
+                  <a:tcPr marL="91440" marR="91440" marT="45720" marB="45720">
+                    <a:solidFill>
+                      <a:srgbClr val="FAFAFA"/>
+                    </a:solidFill>
+                  </a:tcPr>
+                </a:tc>
+                <a:tc>
+                  <a:txBody>
+                    <a:bodyPr/>
+                    <a:lstStyle/>
+                    <a:p>
+                      <a:r>
+                        <a:rPr sz="1800" b="1">
+                          <a:solidFill>
+                            <a:srgbClr val="626262"/>
+                          </a:solidFill>
+                          <a:latin typeface="Arial"/>
+                          <a:ea typeface="Arial"/>
+                          <a:cs typeface="Arial"/>
+                        </a:rPr>
+                        <a:t>Recall</a:t>
+                      </a:r>
+                    </a:p>
+                  </a:txBody>
+                  <a:tcPr marL="91440" marR="91440" marT="45720" marB="45720">
+                    <a:solidFill>
+                      <a:srgbClr val="FAFAFA"/>
+                    </a:solidFill>
+                  </a:tcPr>
+                </a:tc>
+                <a:tc>
+                  <a:txBody>
+                    <a:bodyPr/>
+                    <a:lstStyle/>
+                    <a:p>
+                      <a:r>
+                        <a:rPr sz="1800" b="1">
+                          <a:solidFill>
+                            <a:srgbClr val="626262"/>
+                          </a:solidFill>
+                          <a:latin typeface="Arial"/>
+                          <a:ea typeface="Arial"/>
+                          <a:cs typeface="Arial"/>
+                        </a:rPr>
+                        <a:t>F1</a:t>
+                      </a:r>
+                    </a:p>
+                  </a:txBody>
+                  <a:tcPr marL="91440" marR="91440" marT="45720" marB="45720">
+                    <a:solidFill>
+                      <a:srgbClr val="FAFAFA"/>
+                    </a:solidFill>
+                  </a:tcPr>
+                </a:tc>
+              </a:tr>
+              <a:tr h="628650">
+                <a:tc>
+                  <a:txBody>
+                    <a:bodyPr/>
+                    <a:lstStyle/>
+                    <a:p>
+                      <a:r>
+                        <a:rPr sz="1800" b="0">
+                          <a:solidFill>
+                            <a:srgbClr val="141414"/>
+                          </a:solidFill>
+                          <a:latin typeface="Arial"/>
+                          <a:ea typeface="Arial"/>
+                          <a:cs typeface="Arial"/>
+                        </a:rPr>
+                        <a:t>Original</a:t>
+                      </a:r>
+                    </a:p>
+                  </a:txBody>
+                  <a:tcPr marL="91440" marR="91440" marT="45720" marB="45720">
+                    <a:solidFill>
+                      <a:srgbClr val="FAFAFA"/>
+                    </a:solidFill>
+                  </a:tcPr>
+                </a:tc>
+                <a:tc>
+                  <a:txBody>
+                    <a:bodyPr/>
+                    <a:lstStyle/>
+                    <a:p>
+                      <a:r>
+                        <a:rPr sz="1800" b="0">
+                          <a:solidFill>
+                            <a:srgbClr val="141414"/>
+                          </a:solidFill>
+                          <a:latin typeface="Arial"/>
+                          <a:ea typeface="Arial"/>
+                          <a:cs typeface="Arial"/>
+                        </a:rPr>
+                        <a:t>97.57%</a:t>
+                      </a:r>
+                    </a:p>
+                  </a:txBody>
+                  <a:tcPr marL="91440" marR="91440" marT="45720" marB="45720">
+                    <a:solidFill>
+                      <a:srgbClr val="FAFAFA"/>
+                    </a:solidFill>
+                  </a:tcPr>
+                </a:tc>
+                <a:tc>
+                  <a:txBody>
+                    <a:bodyPr/>
+                    <a:lstStyle/>
+                    <a:p>
+                      <a:r>
+                        <a:rPr sz="1800" b="0">
+                          <a:solidFill>
+                            <a:srgbClr val="141414"/>
+                          </a:solidFill>
+                          <a:latin typeface="Arial"/>
+                          <a:ea typeface="Arial"/>
+                          <a:cs typeface="Arial"/>
+                        </a:rPr>
+                        <a:t>95.54%</a:t>
+                      </a:r>
+                    </a:p>
+                  </a:txBody>
+                  <a:tcPr marL="91440" marR="91440" marT="45720" marB="45720">
+                    <a:solidFill>
+                      <a:srgbClr val="FAFAFA"/>
+                    </a:solidFill>
+                  </a:tcPr>
+                </a:tc>
+                <a:tc>
+                  <a:txBody>
+                    <a:bodyPr/>
+                    <a:lstStyle/>
+                    <a:p>
+                      <a:r>
+                        <a:rPr sz="1800" b="0">
+                          <a:solidFill>
+                            <a:srgbClr val="141414"/>
+                          </a:solidFill>
+                          <a:latin typeface="Arial"/>
+                          <a:ea typeface="Arial"/>
+                          <a:cs typeface="Arial"/>
+                        </a:rPr>
+                        <a:t>96.55%</a:t>
+                      </a:r>
+                    </a:p>
+                  </a:txBody>
+                  <a:tcPr marL="91440" marR="91440" marT="45720" marB="45720">
+                    <a:solidFill>
+                      <a:srgbClr val="FAFAFA"/>
+                    </a:solidFill>
+                  </a:tcPr>
+                </a:tc>
+              </a:tr>
+              <a:tr h="628650">
+                <a:tc>
+                  <a:txBody>
+                    <a:bodyPr/>
+                    <a:lstStyle/>
+                    <a:p>
+                      <a:r>
+                        <a:rPr sz="1800" b="0">
+                          <a:solidFill>
+                            <a:srgbClr val="141414"/>
+                          </a:solidFill>
+                          <a:latin typeface="Arial"/>
+                          <a:ea typeface="Arial"/>
+                          <a:cs typeface="Arial"/>
+                        </a:rPr>
+                        <a:t>Day2 forecast</a:t>
+                      </a:r>
+                    </a:p>
+                  </a:txBody>
+                  <a:tcPr marL="91440" marR="91440" marT="45720" marB="45720">
+                    <a:solidFill>
+                      <a:srgbClr val="FAFAFA"/>
+                    </a:solidFill>
+                  </a:tcPr>
+                </a:tc>
+                <a:tc>
+                  <a:txBody>
+                    <a:bodyPr/>
+                    <a:lstStyle/>
+                    <a:p>
+                      <a:r>
+                        <a:rPr sz="1800" b="0">
+                          <a:solidFill>
+                            <a:srgbClr val="141414"/>
+                          </a:solidFill>
+                          <a:latin typeface="Arial"/>
+                          <a:ea typeface="Arial"/>
+                          <a:cs typeface="Arial"/>
+                        </a:rPr>
+                        <a:t>98.51%</a:t>
+                      </a:r>
+                    </a:p>
+                  </a:txBody>
+                  <a:tcPr marL="91440" marR="91440" marT="45720" marB="45720">
+                    <a:solidFill>
+                      <a:srgbClr val="FAFAFA"/>
+                    </a:solidFill>
+                  </a:tcPr>
+                </a:tc>
+                <a:tc>
+                  <a:txBody>
+                    <a:bodyPr/>
+                    <a:lstStyle/>
+                    <a:p>
+                      <a:r>
+                        <a:rPr sz="1800" b="0">
+                          <a:solidFill>
+                            <a:srgbClr val="141414"/>
+                          </a:solidFill>
+                          <a:latin typeface="Arial"/>
+                          <a:ea typeface="Arial"/>
+                          <a:cs typeface="Arial"/>
+                        </a:rPr>
+                        <a:t>98.32%</a:t>
+                      </a:r>
+                    </a:p>
+                  </a:txBody>
+                  <a:tcPr marL="91440" marR="91440" marT="45720" marB="45720">
+                    <a:solidFill>
+                      <a:srgbClr val="FAFAFA"/>
+                    </a:solidFill>
+                  </a:tcPr>
+                </a:tc>
+                <a:tc>
+                  <a:txBody>
+                    <a:bodyPr/>
+                    <a:lstStyle/>
+                    <a:p>
+                      <a:r>
+                        <a:rPr sz="1800" b="0">
+                          <a:solidFill>
+                            <a:srgbClr val="141414"/>
+                          </a:solidFill>
+                          <a:latin typeface="Arial"/>
+                          <a:ea typeface="Arial"/>
+                          <a:cs typeface="Arial"/>
+                        </a:rPr>
+                        <a:t>98.41%</a:t>
+                      </a:r>
+                    </a:p>
+                  </a:txBody>
+                  <a:tcPr marL="91440" marR="91440" marT="45720" marB="45720">
+                    <a:solidFill>
+                      <a:srgbClr val="FAFAFA"/>
+                    </a:solidFill>
+                  </a:tcPr>
+                </a:tc>
+              </a:tr>
+              <a:tr h="628650">
+                <a:tc>
+                  <a:txBody>
+                    <a:bodyPr/>
+                    <a:lstStyle/>
+                    <a:p>
+                      <a:r>
+                        <a:rPr sz="1800" b="0">
+                          <a:solidFill>
+                            <a:srgbClr val="141414"/>
+                          </a:solidFill>
+                          <a:latin typeface="Arial"/>
+                          <a:ea typeface="Arial"/>
+                          <a:cs typeface="Arial"/>
+                        </a:rPr>
+                        <a:t>Raw analogue</a:t>
+                      </a:r>
+                    </a:p>
+                  </a:txBody>
+                  <a:tcPr marL="91440" marR="91440" marT="45720" marB="45720">
+                    <a:solidFill>
+                      <a:srgbClr val="FAFAFA"/>
+                    </a:solidFill>
+                  </a:tcPr>
+                </a:tc>
+                <a:tc>
+                  <a:txBody>
+                    <a:bodyPr/>
+                    <a:lstStyle/>
+                    <a:p>
+                      <a:r>
+                        <a:rPr sz="1800" b="0">
+                          <a:solidFill>
+                            <a:srgbClr val="141414"/>
+                          </a:solidFill>
+                          <a:latin typeface="Arial"/>
+                          <a:ea typeface="Arial"/>
+                          <a:cs typeface="Arial"/>
+                        </a:rPr>
+                        <a:t>98.41%</a:t>
+                      </a:r>
+                    </a:p>
+                  </a:txBody>
+                  <a:tcPr marL="91440" marR="91440" marT="45720" marB="45720">
+                    <a:solidFill>
+                      <a:srgbClr val="FAFAFA"/>
+                    </a:solidFill>
+                  </a:tcPr>
+                </a:tc>
+                <a:tc>
+                  <a:txBody>
+                    <a:bodyPr/>
+                    <a:lstStyle/>
+                    <a:p>
+                      <a:r>
+                        <a:rPr sz="1800" b="0">
+                          <a:solidFill>
+                            <a:srgbClr val="141414"/>
+                          </a:solidFill>
+                          <a:latin typeface="Arial"/>
+                          <a:ea typeface="Arial"/>
+                          <a:cs typeface="Arial"/>
+                        </a:rPr>
+                        <a:t>98.32%</a:t>
+                      </a:r>
+                    </a:p>
+                  </a:txBody>
+                  <a:tcPr marL="91440" marR="91440" marT="45720" marB="45720">
+                    <a:solidFill>
+                      <a:srgbClr val="FAFAFA"/>
+                    </a:solidFill>
+                  </a:tcPr>
+                </a:tc>
+                <a:tc>
+                  <a:txBody>
+                    <a:bodyPr/>
+                    <a:lstStyle/>
+                    <a:p>
+                      <a:r>
+                        <a:rPr sz="1800" b="0">
+                          <a:solidFill>
+                            <a:srgbClr val="141414"/>
+                          </a:solidFill>
+                          <a:latin typeface="Arial"/>
+                          <a:ea typeface="Arial"/>
+                          <a:cs typeface="Arial"/>
+                        </a:rPr>
+                        <a:t>98.37%</a:t>
+                      </a:r>
+                    </a:p>
+                  </a:txBody>
+                  <a:tcPr marL="91440" marR="91440" marT="45720" marB="45720">
+                    <a:solidFill>
+                      <a:srgbClr val="FAFAFA"/>
+                    </a:solidFill>
+                  </a:tcPr>
+                </a:tc>
+              </a:tr>
+            </a:tbl>
+          </a:graphicData>
+        </a:graphic>
+      </p:graphicFrame>
+      <p:sp>
+        <p:nvSpPr>
+          <p:cNvPr id="13" name="">
             <a:extLst xmlns:a="http://schemas.openxmlformats.org/drawingml/2006/main">
               <a:ext uri="{FF2B5EF4-FFF2-40B4-BE49-F238E27FC236}">
-                <a16:creationId xmlns:a16="http://schemas.microsoft.com/office/drawing/2014/main" id="{9D169926-3AF0-4249-A46E-161E5E93FE89}"/>
+                <a16:creationId xmlns:a16="http://schemas.microsoft.com/office/drawing/2014/main" id="{53CE39CA-ADB6-46B9-AE79-ADA9D47D0555}"/>
               </a:ext>
             </a:extLst>
           </p:cNvPr>
@@ -10077,8 +10536,8 @@
         </p:nvSpPr>
         <p:spPr>
           <a:xfrm xmlns:a="http://schemas.openxmlformats.org/drawingml/2006/main">
-            <a:off x="8753475" y="2009775"/>
-            <a:ext cx="2762250" cy="476250"/>
+            <a:off x="647700" y="5429250"/>
+            <a:ext cx="10810875" cy="447675"/>
           </a:xfrm>
           <a:prstGeom xmlns:a="http://schemas.openxmlformats.org/drawingml/2006/main" prst="rect">
             <a:avLst/>
@@ -10095,35 +10554,35 @@
           <a:lstStyle xmlns:a="http://schemas.openxmlformats.org/drawingml/2006/main"/>
           <a:p xmlns:a="http://schemas.openxmlformats.org/drawingml/2006/main">
             <a:pPr>
-              <a:defRPr sz="2325" b="1">
-                <a:solidFill>
-                  <a:srgbClr val="141414"/>
-                </a:solidFill>
-                <a:latin typeface="Arial"/>
-                <a:ea typeface="Arial"/>
-                <a:cs typeface="Arial"/>
-              </a:defRPr>
-            </a:pPr>
-            <a:r>
-              <a:rPr sz="2325" b="1">
-                <a:solidFill>
-                  <a:srgbClr val="141414"/>
-                </a:solidFill>
-                <a:latin typeface="Arial"/>
-                <a:ea typeface="Arial"/>
-                <a:cs typeface="Arial"/>
-              </a:rPr>
-              <a:t>Precision</a:t>
-            </a:r>
-          </a:p>
-        </p:txBody>
-      </p:sp>
-      <p:sp>
-        <p:nvSpPr>
-          <p:cNvPr id="13" name="">
+              <a:defRPr sz="2100" b="1">
+                <a:solidFill>
+                  <a:srgbClr val="141414"/>
+                </a:solidFill>
+                <a:latin typeface="Arial"/>
+                <a:ea typeface="Arial"/>
+                <a:cs typeface="Arial"/>
+              </a:defRPr>
+            </a:pPr>
+            <a:r>
+              <a:rPr sz="2100" b="1">
+                <a:solidFill>
+                  <a:srgbClr val="141414"/>
+                </a:solidFill>
+                <a:latin typeface="Arial"/>
+                <a:ea typeface="Arial"/>
+                <a:cs typeface="Arial"/>
+              </a:rPr>
+              <a:t>Raw analogue lowers MAE. False alarms rise from 15 to 16.</a:t>
+            </a:r>
+          </a:p>
+        </p:txBody>
+      </p:sp>
+      <p:sp>
+        <p:nvSpPr>
+          <p:cNvPr id="14" name="">
             <a:extLst xmlns:a="http://schemas.openxmlformats.org/drawingml/2006/main">
               <a:ext uri="{FF2B5EF4-FFF2-40B4-BE49-F238E27FC236}">
-                <a16:creationId xmlns:a16="http://schemas.microsoft.com/office/drawing/2014/main" id="{2C611D79-A278-463D-9CB4-4F21D78FE2A6}"/>
+                <a16:creationId xmlns:a16="http://schemas.microsoft.com/office/drawing/2014/main" id="{05EE4F9B-FA34-4A74-A566-BDB5DF35D1D2}"/>
               </a:ext>
             </a:extLst>
           </p:cNvPr>
@@ -10134,167 +10593,7 @@
         </p:nvSpPr>
         <p:spPr>
           <a:xfrm xmlns:a="http://schemas.openxmlformats.org/drawingml/2006/main">
-            <a:off x="8753475" y="2686050"/>
-            <a:ext cx="2828925" cy="962025"/>
-          </a:xfrm>
-          <a:prstGeom xmlns:a="http://schemas.openxmlformats.org/drawingml/2006/main" prst="rect">
-            <a:avLst/>
-          </a:prstGeom>
-          <a:noFill xmlns:a="http://schemas.openxmlformats.org/drawingml/2006/main"/>
-          <a:ln xmlns:a="http://schemas.openxmlformats.org/drawingml/2006/main" w="0">
-            <a:noFill/>
-          </a:ln>
-        </p:spPr>
-        <p:txBody>
-          <a:bodyPr xmlns:a="http://schemas.openxmlformats.org/drawingml/2006/main" anchor="t">
-            <a:noAutofit/>
-          </a:bodyPr>
-          <a:lstStyle xmlns:a="http://schemas.openxmlformats.org/drawingml/2006/main"/>
-          <a:p xmlns:a="http://schemas.openxmlformats.org/drawingml/2006/main">
-            <a:pPr>
-              <a:defRPr sz="1875" b="0">
-                <a:solidFill>
-                  <a:srgbClr val="141414"/>
-                </a:solidFill>
-                <a:latin typeface="Arial"/>
-                <a:ea typeface="Arial"/>
-                <a:cs typeface="Arial"/>
-              </a:defRPr>
-            </a:pPr>
-            <a:r>
-              <a:rPr sz="1875" b="0">
-                <a:solidFill>
-                  <a:srgbClr val="141414"/>
-                </a:solidFill>
-                <a:latin typeface="Arial"/>
-                <a:ea typeface="Arial"/>
-                <a:cs typeface="Arial"/>
-              </a:rPr>
-              <a:t>98.01%   Persistence</a:t>
-            </a:r>
-          </a:p>
-          <a:p xmlns:a="http://schemas.openxmlformats.org/drawingml/2006/main">
-            <a:pPr>
-              <a:defRPr sz="1875" b="0">
-                <a:solidFill>
-                  <a:srgbClr val="141414"/>
-                </a:solidFill>
-                <a:latin typeface="Arial"/>
-                <a:ea typeface="Arial"/>
-                <a:cs typeface="Arial"/>
-              </a:defRPr>
-            </a:pPr>
-            <a:r>
-              <a:rPr sz="1875" b="0">
-                <a:solidFill>
-                  <a:srgbClr val="141414"/>
-                </a:solidFill>
-                <a:latin typeface="Arial"/>
-                <a:ea typeface="Arial"/>
-                <a:cs typeface="Arial"/>
-              </a:rPr>
-              <a:t>96.41%   Classifier</a:t>
-            </a:r>
-          </a:p>
-        </p:txBody>
-      </p:sp>
-      <p:sp>
-        <p:nvSpPr>
-          <p:cNvPr id="14" name="">
-            <a:extLst xmlns:a="http://schemas.openxmlformats.org/drawingml/2006/main">
-              <a:ext uri="{FF2B5EF4-FFF2-40B4-BE49-F238E27FC236}">
-                <a16:creationId xmlns:a16="http://schemas.microsoft.com/office/drawing/2014/main" id="{10655DB9-29D6-4DFE-B7DF-6A9FE859B44B}"/>
-              </a:ext>
-            </a:extLst>
-          </p:cNvPr>
-          <p:cNvSpPr>
-            <a:spLocks xmlns:a="http://schemas.openxmlformats.org/drawingml/2006/main" noGrp="1"/>
-          </p:cNvSpPr>
-          <p:nvPr/>
-        </p:nvSpPr>
-        <p:spPr>
-          <a:xfrm xmlns:a="http://schemas.openxmlformats.org/drawingml/2006/main">
-            <a:off x="8753475" y="4029075"/>
-            <a:ext cx="2857500" cy="1133475"/>
-          </a:xfrm>
-          <a:prstGeom xmlns:a="http://schemas.openxmlformats.org/drawingml/2006/main" prst="rect">
-            <a:avLst/>
-          </a:prstGeom>
-          <a:noFill xmlns:a="http://schemas.openxmlformats.org/drawingml/2006/main"/>
-          <a:ln xmlns:a="http://schemas.openxmlformats.org/drawingml/2006/main" w="0">
-            <a:noFill/>
-          </a:ln>
-        </p:spPr>
-        <p:txBody>
-          <a:bodyPr xmlns:a="http://schemas.openxmlformats.org/drawingml/2006/main" anchor="t">
-            <a:noAutofit/>
-          </a:bodyPr>
-          <a:lstStyle xmlns:a="http://schemas.openxmlformats.org/drawingml/2006/main"/>
-          <a:p xmlns:a="http://schemas.openxmlformats.org/drawingml/2006/main">
-            <a:pPr>
-              <a:defRPr sz="2400" b="1">
-                <a:solidFill>
-                  <a:srgbClr val="141414"/>
-                </a:solidFill>
-                <a:latin typeface="Arial"/>
-                <a:ea typeface="Arial"/>
-                <a:cs typeface="Arial"/>
-              </a:defRPr>
-            </a:pPr>
-            <a:r>
-              <a:rPr sz="2400" b="1">
-                <a:solidFill>
-                  <a:srgbClr val="141414"/>
-                </a:solidFill>
-                <a:latin typeface="Arial"/>
-                <a:ea typeface="Arial"/>
-                <a:cs typeface="Arial"/>
-              </a:rPr>
-              <a:t>Lower F1</a:t>
-            </a:r>
-          </a:p>
-          <a:p xmlns:a="http://schemas.openxmlformats.org/drawingml/2006/main">
-            <a:pPr>
-              <a:defRPr sz="2400" b="1">
-                <a:solidFill>
-                  <a:srgbClr val="141414"/>
-                </a:solidFill>
-                <a:latin typeface="Arial"/>
-                <a:ea typeface="Arial"/>
-                <a:cs typeface="Arial"/>
-              </a:defRPr>
-            </a:pPr>
-            <a:r>
-              <a:rPr sz="2400" b="1">
-                <a:solidFill>
-                  <a:srgbClr val="141414"/>
-                </a:solidFill>
-                <a:latin typeface="Arial"/>
-                <a:ea typeface="Arial"/>
-                <a:cs typeface="Arial"/>
-              </a:rPr>
-              <a:t>0.9745 vs 0.9777</a:t>
-            </a:r>
-          </a:p>
-        </p:txBody>
-      </p:sp>
-      <p:sp>
-        <p:nvSpPr>
-          <p:cNvPr id="15" name="">
-            <a:extLst xmlns:a="http://schemas.openxmlformats.org/drawingml/2006/main">
-              <a:ext uri="{FF2B5EF4-FFF2-40B4-BE49-F238E27FC236}">
-                <a16:creationId xmlns:a16="http://schemas.microsoft.com/office/drawing/2014/main" id="{24AA3110-63AB-480A-8174-9836E8E72EFC}"/>
-              </a:ext>
-            </a:extLst>
-          </p:cNvPr>
-          <p:cNvSpPr>
-            <a:spLocks xmlns:a="http://schemas.openxmlformats.org/drawingml/2006/main" noGrp="1"/>
-          </p:cNvSpPr>
-          <p:nvPr/>
-        </p:nvSpPr>
-        <p:spPr>
-          <a:xfrm xmlns:a="http://schemas.openxmlformats.org/drawingml/2006/main">
-            <a:off x="647700" y="5934075"/>
+            <a:off x="647700" y="6105525"/>
             <a:ext cx="10572750" cy="476250"/>
           </a:xfrm>
           <a:prstGeom xmlns:a="http://schemas.openxmlformats.org/drawingml/2006/main" prst="rect">
@@ -10330,7 +10629,7 @@
                 <a:ea typeface="Arial"/>
                 <a:cs typeface="Arial"/>
               </a:rPr>
-              <a:t>Validation selected the candidate. The test was already inspected. Fresh holdout needed.</a:t>
+              <a:t>Model-derived reference. Previously inspected test. Historical forecast publication time unverified.</a:t>
             </a:r>
           </a:p>
         </p:txBody>
@@ -10485,7 +10784,7 @@
           <p:cNvPr id="10" name="">
             <a:extLst xmlns:a="http://schemas.openxmlformats.org/drawingml/2006/main">
               <a:ext uri="{FF2B5EF4-FFF2-40B4-BE49-F238E27FC236}">
-                <a16:creationId xmlns:a16="http://schemas.microsoft.com/office/drawing/2014/main" id="{86032CB8-5889-4BEC-A45F-DF141B2FE00C}"/>
+                <a16:creationId xmlns:a16="http://schemas.microsoft.com/office/drawing/2014/main" id="{C5409487-9299-4234-99D0-DB9E3EBDE018}"/>
               </a:ext>
             </a:extLst>
           </p:cNvPr>
@@ -10542,7 +10841,7 @@
           <p:cNvPr id="11" name="">
             <a:extLst xmlns:a="http://schemas.openxmlformats.org/drawingml/2006/main">
               <a:ext uri="{FF2B5EF4-FFF2-40B4-BE49-F238E27FC236}">
-                <a16:creationId xmlns:a16="http://schemas.microsoft.com/office/drawing/2014/main" id="{2D1A15C3-964B-4D55-B909-9B36CFAF650B}"/>
+                <a16:creationId xmlns:a16="http://schemas.microsoft.com/office/drawing/2014/main" id="{8FBC7EC8-8BC8-4DF1-9DFA-E6205E406F46}"/>
               </a:ext>
             </a:extLst>
           </p:cNvPr>
@@ -10622,7 +10921,7 @@
           <p:cNvPr id="12" name="">
             <a:extLst xmlns:a="http://schemas.openxmlformats.org/drawingml/2006/main">
               <a:ext uri="{FF2B5EF4-FFF2-40B4-BE49-F238E27FC236}">
-                <a16:creationId xmlns:a16="http://schemas.microsoft.com/office/drawing/2014/main" id="{AC21123F-EA8F-4DDC-8274-23C409CBE313}"/>
+                <a16:creationId xmlns:a16="http://schemas.microsoft.com/office/drawing/2014/main" id="{E33C2971-1024-4D30-9373-778A7DE70437}"/>
               </a:ext>
             </a:extLst>
           </p:cNvPr>
@@ -10679,7 +10978,7 @@
           <p:cNvPr id="13" name="">
             <a:extLst xmlns:a="http://schemas.openxmlformats.org/drawingml/2006/main">
               <a:ext uri="{FF2B5EF4-FFF2-40B4-BE49-F238E27FC236}">
-                <a16:creationId xmlns:a16="http://schemas.microsoft.com/office/drawing/2014/main" id="{CAE7942A-A975-42DE-BAE0-DCBDD6254C6B}"/>
+                <a16:creationId xmlns:a16="http://schemas.microsoft.com/office/drawing/2014/main" id="{BDC0D349-EA96-4298-BFAA-109990948B80}"/>
               </a:ext>
             </a:extLst>
           </p:cNvPr>
@@ -10759,7 +11058,7 @@
           <p:cNvPr id="14" name="">
             <a:extLst xmlns:a="http://schemas.openxmlformats.org/drawingml/2006/main">
               <a:ext uri="{FF2B5EF4-FFF2-40B4-BE49-F238E27FC236}">
-                <a16:creationId xmlns:a16="http://schemas.microsoft.com/office/drawing/2014/main" id="{AEA57ACE-0EA4-4193-A51E-49C0D0E9907F}"/>
+                <a16:creationId xmlns:a16="http://schemas.microsoft.com/office/drawing/2014/main" id="{B230E63E-137B-490F-868C-A0F19345D1B4}"/>
               </a:ext>
             </a:extLst>
           </p:cNvPr>
@@ -10816,7 +11115,7 @@
           <p:cNvPr id="15" name="">
             <a:extLst xmlns:a="http://schemas.openxmlformats.org/drawingml/2006/main">
               <a:ext uri="{FF2B5EF4-FFF2-40B4-BE49-F238E27FC236}">
-                <a16:creationId xmlns:a16="http://schemas.microsoft.com/office/drawing/2014/main" id="{B77AE891-2783-4B4C-8ECC-3A40DABA347D}"/>
+                <a16:creationId xmlns:a16="http://schemas.microsoft.com/office/drawing/2014/main" id="{59088507-36BF-4623-8899-DED7B636F9A3}"/>
               </a:ext>
             </a:extLst>
           </p:cNvPr>

</xml_diff>

<commit_message>
Prepare current forecast review pack and team assets
</commit_message>
<xml_diff>
--- a/app/delivery/Aktina-Pafos-2026.pptx
+++ b/app/delivery/Aktina-Pafos-2026.pptx
@@ -2,24 +2,24 @@
 <file path=ppt/presentation.xml><?xml version="1.0" encoding="utf-8"?>
 <p:presentation xmlns:p="http://schemas.openxmlformats.org/presentationml/2006/main">
   <p:sldMasterIdLst>
-    <p:sldMasterId xmlns:r="http://schemas.openxmlformats.org/officeDocument/2006/relationships" id="2147483648" r:id="Rdd8190bb43ff4ce8"/>
+    <p:sldMasterId xmlns:r="http://schemas.openxmlformats.org/officeDocument/2006/relationships" id="2147483648" r:id="Ra4279cb8c9d849b7"/>
   </p:sldMasterIdLst>
   <p:notesMasterIdLst>
-    <p:notesMasterId xmlns:r="http://schemas.openxmlformats.org/officeDocument/2006/relationships" r:id="R6c14cfd3511f4b78"/>
+    <p:notesMasterId xmlns:r="http://schemas.openxmlformats.org/officeDocument/2006/relationships" r:id="Ra164705d9b6f441f"/>
   </p:notesMasterIdLst>
   <p:sldIdLst>
-    <p:sldId xmlns:r="http://schemas.openxmlformats.org/officeDocument/2006/relationships" id="256" r:id="Rdd32b86cb03b4a3c"/>
-    <p:sldId xmlns:r="http://schemas.openxmlformats.org/officeDocument/2006/relationships" id="257" r:id="Rfad8e00a619b44c7"/>
-    <p:sldId xmlns:r="http://schemas.openxmlformats.org/officeDocument/2006/relationships" id="258" r:id="R2fd088a54f7a4e53"/>
-    <p:sldId xmlns:r="http://schemas.openxmlformats.org/officeDocument/2006/relationships" id="259" r:id="R79a1bc272f9349e9"/>
-    <p:sldId xmlns:r="http://schemas.openxmlformats.org/officeDocument/2006/relationships" id="260" r:id="R09b26e99dc8d4c93"/>
-    <p:sldId xmlns:r="http://schemas.openxmlformats.org/officeDocument/2006/relationships" id="261" r:id="Rf4d89237e1ea491e"/>
-    <p:sldId xmlns:r="http://schemas.openxmlformats.org/officeDocument/2006/relationships" id="262" r:id="R953ab84bab5c404a"/>
-    <p:sldId xmlns:r="http://schemas.openxmlformats.org/officeDocument/2006/relationships" id="263" r:id="R3fc7d60994a14251"/>
-    <p:sldId xmlns:r="http://schemas.openxmlformats.org/officeDocument/2006/relationships" id="264" r:id="R1a72e22aa8724a00"/>
-    <p:sldId xmlns:r="http://schemas.openxmlformats.org/officeDocument/2006/relationships" id="265" r:id="R64136b0054e44a0a"/>
-    <p:sldId xmlns:r="http://schemas.openxmlformats.org/officeDocument/2006/relationships" id="266" r:id="R9ec9492cf5724788"/>
-    <p:sldId xmlns:r="http://schemas.openxmlformats.org/officeDocument/2006/relationships" id="267" r:id="R4200c0cedd204dd3"/>
+    <p:sldId xmlns:r="http://schemas.openxmlformats.org/officeDocument/2006/relationships" id="256" r:id="R9461c196fd2d447a"/>
+    <p:sldId xmlns:r="http://schemas.openxmlformats.org/officeDocument/2006/relationships" id="257" r:id="Re8db080fc8654124"/>
+    <p:sldId xmlns:r="http://schemas.openxmlformats.org/officeDocument/2006/relationships" id="258" r:id="Rde978c37d19245d6"/>
+    <p:sldId xmlns:r="http://schemas.openxmlformats.org/officeDocument/2006/relationships" id="259" r:id="R90fed0f64c21468d"/>
+    <p:sldId xmlns:r="http://schemas.openxmlformats.org/officeDocument/2006/relationships" id="260" r:id="R040fb4c5e7c548f9"/>
+    <p:sldId xmlns:r="http://schemas.openxmlformats.org/officeDocument/2006/relationships" id="261" r:id="R00cdfcb724a84d37"/>
+    <p:sldId xmlns:r="http://schemas.openxmlformats.org/officeDocument/2006/relationships" id="262" r:id="R4bb0405ea4ac4883"/>
+    <p:sldId xmlns:r="http://schemas.openxmlformats.org/officeDocument/2006/relationships" id="263" r:id="R81248c1fe87f4405"/>
+    <p:sldId xmlns:r="http://schemas.openxmlformats.org/officeDocument/2006/relationships" id="264" r:id="R2923c18bb9a04cb5"/>
+    <p:sldId xmlns:r="http://schemas.openxmlformats.org/officeDocument/2006/relationships" id="265" r:id="Re7c07187bc044fdf"/>
+    <p:sldId xmlns:r="http://schemas.openxmlformats.org/officeDocument/2006/relationships" id="266" r:id="R7ab37ed0ed4a4302"/>
+    <p:sldId xmlns:r="http://schemas.openxmlformats.org/officeDocument/2006/relationships" id="267" r:id="Rb5b90138911047b4"/>
   </p:sldIdLst>
   <p:sldSz cx="12192000" cy="6858000"/>
   <p:notesSz cx="6858000" cy="9144000"/>
@@ -693,7 +693,7 @@
           </a:p>
           <a:p xmlns:a="http://schemas.openxmlformats.org/drawingml/2006/main">
             <a:r>
-              <a:t>First, confirm which retained schedule should be submitted and rehearse the offline demo together. For the next model, controlled comparisons can test solar geometry, clear-sky normalisation and forecasts of tomorrow's cloud that were available today. Each addition needs a controlled comparison, fixed time boundaries and a fresh holdout. Difficult test hours must stay in the evaluation.</a:t>
+              <a:t>Stefanos's v2 source and validation predictions have been received and merged without altering his original files. A small correction of its chronology-safe refit is now evaluated and shown in the historical forecast viewer. On all 3,566 validation hours, precision is 94.08 percent, recall 88.24 percent and F1 91.06 percent. There are 270 true positives, 17 false positives, 36 false negatives and 3,243 true negatives.</a:t>
             </a:r>
           </a:p>
           <a:p xmlns:a="http://schemas.openxmlformats.org/drawingml/2006/main">
@@ -703,7 +703,7 @@
           </a:p>
           <a:p xmlns:a="http://schemas.openxmlformats.org/drawingml/2006/main">
             <a:r>
-              <a:t>For a pilot, we need an operator, a data contact and an agreed measurement plan. We would check plant constraints, demand, tariffs and available curtailment signals before considering an operational trial. The business case should follow measured results rather than assumed savings.</a:t>
+              <a:t>Supplied v2 at its original threshold scores 91.29 percent precision, 85.62 percent recall and 88.36 percent F1. The separate 008 comparison scores 92.81 percent precision, 88.56 percent recall and 90.64 percent F1. The correction has four fewer false alarms than 008 but misses one additional hour. Its higher observed F1 does not establish superiority on unseen data. The paired-day interval for the F1 difference against 008 includes zero, from −1.6061 to +2.6215 percentage points. The validation period has been reused. No new v2 test predictions were supplied or scored.</a:t>
             </a:r>
           </a:p>
           <a:p xmlns:a="http://schemas.openxmlformats.org/drawingml/2006/main">
@@ -713,7 +713,17 @@
           </a:p>
           <a:p xmlns:a="http://schemas.openxmlformats.org/drawingml/2006/main">
             <a:r>
-              <a:t>Source cue: `app/handoff/MODEL-V2-FEEDBACK.md`. These are proposed v2 directions, not a completed v2 model or guaranteed gains. Two team rehearsals remain uncompleted.</a:t>
+              <a:t>The correction changes high-solar event calls. Its radiation curve is the separately retained v2 refit, not an alteration of the supplied curve. It does not change the demonstration schedule or establish operational savings. The intended submission schedule still needs team confirmation. For a pilot, we need an operator, a data contact and an agreed measurement plan. The presentation lead can use these checked facts in the final slides and rehearse the chosen demonstration.</a:t>
+            </a:r>
+          </a:p>
+          <a:p xmlns:a="http://schemas.openxmlformats.org/drawingml/2006/main">
+            <a:r>
+              <a:t/>
+            </a:r>
+          </a:p>
+          <a:p xmlns:a="http://schemas.openxmlformats.org/drawingml/2006/main">
+            <a:r>
+              <a:t>Source cue: `app/experiments/v2-019/result/summary.json` and `app/experiments/v2-019/review/review.json`. Event truth is strictly above 600 W/m². Source files, saved coefficients and complete matched-hour counts are retained. Two team rehearsals remain uncompleted.</a:t>
             </a:r>
           </a:p>
           <a:p xmlns:a="http://schemas.openxmlformats.org/drawingml/2006/main">
@@ -1438,7 +1448,7 @@
           </a:p>
           <a:p xmlns:a="http://schemas.openxmlformats.org/drawingml/2006/main">
             <a:r>
-              <a:t>Fallback: `Aktina-Backup-Final.mp4`, 44 seconds, no audio. It is a product screenshot walkthrough, not a live interaction recording. Do not play both sequences. Online address: https://aktina-pafos-2026.vercel.app/.</a:t>
+              <a:t>Fallback: `Aktina-Backup-Final.mp4`, 44 seconds, no audio. It is a historical screenshot walkthrough that predates the current forecast view, not a live interaction recording or a showcase of the new event correction. Do not play both sequences. Online address: https://aktina-pafos-2026.vercel.app/.</a:t>
             </a:r>
           </a:p>
           <a:p xmlns:a="http://schemas.openxmlformats.org/drawingml/2006/main">
@@ -1668,7 +1678,7 @@
           </a:p>
           <a:p xmlns:a="http://schemas.openxmlformats.org/drawingml/2006/main">
             <a:r>
-              <a:t>The strongest completed progress comes from additional weather information. On the same 3,567 original test hours, the original model has MAE 14.27 W/m². The fixed archived day2 forecast has MAE 8.81, and raw residual analogues reduce it to 6.92. Precision, recall and F1 are 97.57%, 95.54%, 96.55% for the original model; 98.51%, 98.32%, 98.41% for the archived forecast; and 98.41%, 98.32%, 98.37% for the raw analogue. These are retrospective comparisons against the original model-derived reference.</a:t>
+              <a:t>The earlier original-test comparison examines additional weather information. On the same 3,567 original test hours, the original model has MAE 14.27 W/m². The fixed archived day2 forecast has MAE 8.81, and raw residual analogues reduce it to 6.92. Precision, recall and F1 are 97.57%, 95.54%, 96.55% for the original model; 98.51%, 98.32%, 98.41% for the archived forecast; and 98.41%, 98.32%, 98.37% for the raw analogue. These are retrospective comparisons against the original model-derived reference.</a:t>
             </a:r>
           </a:p>
           <a:p xmlns:a="http://schemas.openxmlformats.org/drawingml/2006/main">
@@ -1678,7 +1688,7 @@
           </a:p>
           <a:p xmlns:a="http://schemas.openxmlformats.org/drawingml/2006/main">
             <a:r>
-              <a:t>The analogue reuses 64 historical residuals to form hourly scenarios. Its lower MAE comes with one extra false alarm: 16 instead of the archived forecast's 15, with 17 misses for both. Validation retains the fixed archived forecast. On the harder 3,566-hour validation period its F1 is 90.08%, compared with 80.07% for the original model and 89.95% for raw analogues. No learned candidate is promoted. The original model remains intact.</a:t>
+              <a:t>The analogue reuses 64 historical residuals to form hourly scenarios. Its lower MAE comes with one extra false alarm: 16 instead of the archived forecast's 15, with 17 misses for both. Validation retains the fixed archived forecast. On the harder 3,566-hour validation period its F1 is 90.08%, compared with 80.07% for the original model and 89.95% for raw analogues. That archived-weather comparison did not promote a learned candidate. The original model remains intact. Slide 11 covers the later completed v2 validation extension.</a:t>
             </a:r>
           </a:p>
           <a:p xmlns:a="http://schemas.openxmlformats.org/drawingml/2006/main">
@@ -1906,7 +1916,7 @@
   </p:cSld>
   <p:clrMap bg1="lt1" tx1="dk1" bg2="lt2" tx2="dk2" accent1="accent1" accent2="accent2" accent3="accent3" accent4="accent4" accent5="accent5" accent6="accent6" hlink="hlink" folHlink="folHlink"/>
   <p:sldLayoutIdLst>
-    <p:sldLayoutId xmlns:r="http://schemas.openxmlformats.org/officeDocument/2006/relationships" id="2147483649" r:id="R7801477d537245a7"/>
+    <p:sldLayoutId xmlns:r="http://schemas.openxmlformats.org/officeDocument/2006/relationships" id="2147483649" r:id="R783ba9555acc4bf4"/>
   </p:sldLayoutIdLst>
   <p:txStyles>
     <p:titleStyle>
@@ -4049,7 +4059,7 @@
           <p:cNvPr id="8" name="">
             <a:extLst xmlns:a="http://schemas.openxmlformats.org/drawingml/2006/main">
               <a:ext uri="{FF2B5EF4-FFF2-40B4-BE49-F238E27FC236}">
-                <a16:creationId xmlns:a16="http://schemas.microsoft.com/office/drawing/2014/main" id="{43BF777E-9F57-473C-A3C9-28F2F9753FCB}"/>
+                <a16:creationId xmlns:a16="http://schemas.microsoft.com/office/drawing/2014/main" id="{A8CEA5A6-EF1D-43D9-A389-A7AD9991D7C4}"/>
               </a:ext>
             </a:extLst>
           </p:cNvPr>
@@ -4106,7 +4116,7 @@
           <p:cNvPr id="9" name="">
             <a:extLst xmlns:a="http://schemas.openxmlformats.org/drawingml/2006/main">
               <a:ext uri="{FF2B5EF4-FFF2-40B4-BE49-F238E27FC236}">
-                <a16:creationId xmlns:a16="http://schemas.microsoft.com/office/drawing/2014/main" id="{1D1F34AE-6953-4E72-99EC-8759854E3569}"/>
+                <a16:creationId xmlns:a16="http://schemas.microsoft.com/office/drawing/2014/main" id="{58AA97C4-965A-43BD-BD0A-7D1EBEBA4035}"/>
               </a:ext>
             </a:extLst>
           </p:cNvPr>
@@ -4186,7 +4196,7 @@
           <p:cNvPr id="10" name="">
             <a:extLst xmlns:a="http://schemas.openxmlformats.org/drawingml/2006/main">
               <a:ext uri="{FF2B5EF4-FFF2-40B4-BE49-F238E27FC236}">
-                <a16:creationId xmlns:a16="http://schemas.microsoft.com/office/drawing/2014/main" id="{23B99550-EA0C-4EAB-A7A6-F014451DF4D4}"/>
+                <a16:creationId xmlns:a16="http://schemas.microsoft.com/office/drawing/2014/main" id="{AE42E782-6C3C-405B-97AD-82DCA40E7063}"/>
               </a:ext>
             </a:extLst>
           </p:cNvPr>
@@ -4243,7 +4253,7 @@
           <p:cNvPr id="11" name="">
             <a:extLst xmlns:a="http://schemas.openxmlformats.org/drawingml/2006/main">
               <a:ext uri="{FF2B5EF4-FFF2-40B4-BE49-F238E27FC236}">
-                <a16:creationId xmlns:a16="http://schemas.microsoft.com/office/drawing/2014/main" id="{2538F9F1-AD11-479C-90A2-886FA940449E}"/>
+                <a16:creationId xmlns:a16="http://schemas.microsoft.com/office/drawing/2014/main" id="{9D460E6E-93CD-4988-9E71-D02F20C2EB81}"/>
               </a:ext>
             </a:extLst>
           </p:cNvPr>
@@ -4468,7 +4478,7 @@
           <p:cNvPr id="9" name="">
             <a:extLst xmlns:a="http://schemas.openxmlformats.org/drawingml/2006/main">
               <a:ext uri="{FF2B5EF4-FFF2-40B4-BE49-F238E27FC236}">
-                <a16:creationId xmlns:a16="http://schemas.microsoft.com/office/drawing/2014/main" id="{E0289C5B-F284-45A9-BF94-3BB3868A32B0}"/>
+                <a16:creationId xmlns:a16="http://schemas.microsoft.com/office/drawing/2014/main" id="{615038B4-4662-4E32-9994-ACF27CD0726E}"/>
               </a:ext>
             </a:extLst>
           </p:cNvPr>
@@ -4525,7 +4535,7 @@
           <p:cNvPr id="10" name="">
             <a:extLst xmlns:a="http://schemas.openxmlformats.org/drawingml/2006/main">
               <a:ext uri="{FF2B5EF4-FFF2-40B4-BE49-F238E27FC236}">
-                <a16:creationId xmlns:a16="http://schemas.microsoft.com/office/drawing/2014/main" id="{8CA7DC03-7151-4A0D-B240-C776B45DB1B0}"/>
+                <a16:creationId xmlns:a16="http://schemas.microsoft.com/office/drawing/2014/main" id="{083E2343-0E21-40ED-87A5-51F23D6FDF83}"/>
               </a:ext>
             </a:extLst>
           </p:cNvPr>
@@ -4651,7 +4661,7 @@
           <p:cNvPr id="11" name="">
             <a:extLst xmlns:a="http://schemas.openxmlformats.org/drawingml/2006/main">
               <a:ext uri="{FF2B5EF4-FFF2-40B4-BE49-F238E27FC236}">
-                <a16:creationId xmlns:a16="http://schemas.microsoft.com/office/drawing/2014/main" id="{2F842AAF-8387-4F30-8E7C-7C54E07F7A50}"/>
+                <a16:creationId xmlns:a16="http://schemas.microsoft.com/office/drawing/2014/main" id="{02ABF6FB-A50A-4985-A34C-6D4D56D53DF9}"/>
               </a:ext>
             </a:extLst>
           </p:cNvPr>
@@ -4708,7 +4718,7 @@
           <p:cNvPr id="12" name="">
             <a:extLst xmlns:a="http://schemas.openxmlformats.org/drawingml/2006/main">
               <a:ext uri="{FF2B5EF4-FFF2-40B4-BE49-F238E27FC236}">
-                <a16:creationId xmlns:a16="http://schemas.microsoft.com/office/drawing/2014/main" id="{00DD8D04-D524-45A0-85C9-9D846FF9335D}"/>
+                <a16:creationId xmlns:a16="http://schemas.microsoft.com/office/drawing/2014/main" id="{4D4937CB-BCBA-4EBF-88B1-A42FE29CDCB5}"/>
               </a:ext>
             </a:extLst>
           </p:cNvPr>
@@ -4834,7 +4844,7 @@
           <p:cNvPr id="13" name="">
             <a:extLst xmlns:a="http://schemas.openxmlformats.org/drawingml/2006/main">
               <a:ext uri="{FF2B5EF4-FFF2-40B4-BE49-F238E27FC236}">
-                <a16:creationId xmlns:a16="http://schemas.microsoft.com/office/drawing/2014/main" id="{8EB16AF2-ABD5-4865-9BD1-E688EE736743}"/>
+                <a16:creationId xmlns:a16="http://schemas.microsoft.com/office/drawing/2014/main" id="{30AE9B37-5BB7-4290-B9D2-0C5C4CF909A9}"/>
               </a:ext>
             </a:extLst>
           </p:cNvPr>
@@ -5036,7 +5046,7 @@
           <p:cNvPr id="16" name="">
             <a:extLst xmlns:a="http://schemas.openxmlformats.org/drawingml/2006/main">
               <a:ext uri="{FF2B5EF4-FFF2-40B4-BE49-F238E27FC236}">
-                <a16:creationId xmlns:a16="http://schemas.microsoft.com/office/drawing/2014/main" id="{1D28994E-C380-4FAF-A645-D0104744AB9F}"/>
+                <a16:creationId xmlns:a16="http://schemas.microsoft.com/office/drawing/2014/main" id="{5D68FEDF-15FB-44B8-B38A-58D0765B7109}"/>
               </a:ext>
             </a:extLst>
           </p:cNvPr>
@@ -5093,7 +5103,7 @@
           <p:cNvPr id="17" name="">
             <a:extLst xmlns:a="http://schemas.openxmlformats.org/drawingml/2006/main">
               <a:ext uri="{FF2B5EF4-FFF2-40B4-BE49-F238E27FC236}">
-                <a16:creationId xmlns:a16="http://schemas.microsoft.com/office/drawing/2014/main" id="{DB7081B7-6E75-4721-B68C-DB4824248E6A}"/>
+                <a16:creationId xmlns:a16="http://schemas.microsoft.com/office/drawing/2014/main" id="{BE67AD3F-107D-40D1-9919-C470013DFAC4}"/>
               </a:ext>
             </a:extLst>
           </p:cNvPr>
@@ -5201,7 +5211,7 @@
           <p:cNvPr id="18" name="">
             <a:extLst xmlns:a="http://schemas.openxmlformats.org/drawingml/2006/main">
               <a:ext uri="{FF2B5EF4-FFF2-40B4-BE49-F238E27FC236}">
-                <a16:creationId xmlns:a16="http://schemas.microsoft.com/office/drawing/2014/main" id="{8DF1B4F8-A75C-4C9C-B2E8-4C02F9336B53}"/>
+                <a16:creationId xmlns:a16="http://schemas.microsoft.com/office/drawing/2014/main" id="{6B882090-BA9E-4E08-9161-27CAF140EDDC}"/>
               </a:ext>
             </a:extLst>
           </p:cNvPr>
@@ -5248,7 +5258,7 @@
                 <a:ea typeface="Arial"/>
                 <a:cs typeface="Arial"/>
               </a:rPr>
-              <a:t>Model v2</a:t>
+              <a:t>V2 + correction</a:t>
             </a:r>
           </a:p>
         </p:txBody>
@@ -5258,7 +5268,7 @@
           <p:cNvPr id="19" name="">
             <a:extLst xmlns:a="http://schemas.openxmlformats.org/drawingml/2006/main">
               <a:ext uri="{FF2B5EF4-FFF2-40B4-BE49-F238E27FC236}">
-                <a16:creationId xmlns:a16="http://schemas.microsoft.com/office/drawing/2014/main" id="{F2DE1D43-9658-413B-9DCA-D301BFC41EC5}"/>
+                <a16:creationId xmlns:a16="http://schemas.microsoft.com/office/drawing/2014/main" id="{A5ED4E7E-8B12-4B35-B7C3-7A081E597E5E}"/>
               </a:ext>
             </a:extLst>
           </p:cNvPr>
@@ -5305,7 +5315,7 @@
                 <a:ea typeface="Arial"/>
                 <a:cs typeface="Arial"/>
               </a:rPr>
-              <a:t>Controlled features</a:t>
+              <a:t>P 94.08%  R 88.24%</a:t>
             </a:r>
           </a:p>
           <a:p xmlns:a="http://schemas.openxmlformats.org/drawingml/2006/main">
@@ -5328,7 +5338,7 @@
                 <a:ea typeface="Arial"/>
                 <a:cs typeface="Arial"/>
               </a:rPr>
-              <a:t>Fixed time boundaries</a:t>
+              <a:t>F1 91.06%</a:t>
             </a:r>
           </a:p>
           <a:p xmlns:a="http://schemas.openxmlformats.org/drawingml/2006/main">
@@ -5356,7 +5366,7 @@
                 <a:ea typeface="Arial"/>
                 <a:cs typeface="Arial"/>
               </a:rPr>
-              <a:t>Fresh held-out period</a:t>
+              <a:t>3,566 validation hours</a:t>
             </a:r>
           </a:p>
         </p:txBody>
@@ -5366,7 +5376,7 @@
           <p:cNvPr id="20" name="">
             <a:extLst xmlns:a="http://schemas.openxmlformats.org/drawingml/2006/main">
               <a:ext uri="{FF2B5EF4-FFF2-40B4-BE49-F238E27FC236}">
-                <a16:creationId xmlns:a16="http://schemas.microsoft.com/office/drawing/2014/main" id="{6D0D76AB-F32F-4C45-87A6-673F9BE48050}"/>
+                <a16:creationId xmlns:a16="http://schemas.microsoft.com/office/drawing/2014/main" id="{491671B1-0B2A-4007-9AD6-D78F34E80E1D}"/>
               </a:ext>
             </a:extLst>
           </p:cNvPr>
@@ -5423,7 +5433,7 @@
           <p:cNvPr id="21" name="">
             <a:extLst xmlns:a="http://schemas.openxmlformats.org/drawingml/2006/main">
               <a:ext uri="{FF2B5EF4-FFF2-40B4-BE49-F238E27FC236}">
-                <a16:creationId xmlns:a16="http://schemas.microsoft.com/office/drawing/2014/main" id="{43C9F774-3D84-4D4D-9BE7-AFA731A87D8B}"/>
+                <a16:creationId xmlns:a16="http://schemas.microsoft.com/office/drawing/2014/main" id="{DA6BA50C-C6A2-44EC-842E-70EC7FE3100E}"/>
               </a:ext>
             </a:extLst>
           </p:cNvPr>
@@ -5531,7 +5541,7 @@
           <p:cNvPr id="22" name="">
             <a:extLst xmlns:a="http://schemas.openxmlformats.org/drawingml/2006/main">
               <a:ext uri="{FF2B5EF4-FFF2-40B4-BE49-F238E27FC236}">
-                <a16:creationId xmlns:a16="http://schemas.microsoft.com/office/drawing/2014/main" id="{4C62EF93-627B-4E58-8228-DD58E5C15C13}"/>
+                <a16:creationId xmlns:a16="http://schemas.microsoft.com/office/drawing/2014/main" id="{BE25DB22-2692-4E92-8EF4-FB605FA9A7DA}"/>
               </a:ext>
             </a:extLst>
           </p:cNvPr>
@@ -5578,7 +5588,7 @@
                 <a:ea typeface="Arial"/>
                 <a:cs typeface="Arial"/>
               </a:rPr>
-              <a:t>V2 is pending. Improvements and pilot benefits must be demonstrated.</a:t>
+              <a:t>Versus 008: 4 fewer false alarms, 1 extra miss. Historical validation, not an unseen-data result.</a:t>
             </a:r>
           </a:p>
         </p:txBody>
@@ -5733,7 +5743,7 @@
           <p:cNvPr id="10" name="">
             <a:extLst xmlns:a="http://schemas.openxmlformats.org/drawingml/2006/main">
               <a:ext uri="{FF2B5EF4-FFF2-40B4-BE49-F238E27FC236}">
-                <a16:creationId xmlns:a16="http://schemas.microsoft.com/office/drawing/2014/main" id="{0A732C04-2D58-447E-9560-41AD063C3D92}"/>
+                <a16:creationId xmlns:a16="http://schemas.microsoft.com/office/drawing/2014/main" id="{BEB90DBE-3B10-42A9-9EB3-B24F8C20D09C}"/>
               </a:ext>
             </a:extLst>
           </p:cNvPr>
@@ -5813,7 +5823,7 @@
           <p:cNvPr id="11" name="">
             <a:extLst xmlns:a="http://schemas.openxmlformats.org/drawingml/2006/main">
               <a:ext uri="{FF2B5EF4-FFF2-40B4-BE49-F238E27FC236}">
-                <a16:creationId xmlns:a16="http://schemas.microsoft.com/office/drawing/2014/main" id="{F9FA8C06-F17B-4E4C-873C-E8DD6C1F1B68}"/>
+                <a16:creationId xmlns:a16="http://schemas.microsoft.com/office/drawing/2014/main" id="{857F187F-2B81-4D86-8B62-E1DB5DBE660B}"/>
               </a:ext>
             </a:extLst>
           </p:cNvPr>
@@ -5870,7 +5880,7 @@
           <p:cNvPr id="12" name="">
             <a:extLst xmlns:a="http://schemas.openxmlformats.org/drawingml/2006/main">
               <a:ext uri="{FF2B5EF4-FFF2-40B4-BE49-F238E27FC236}">
-                <a16:creationId xmlns:a16="http://schemas.microsoft.com/office/drawing/2014/main" id="{EF456036-CD9B-484E-AEED-925DEADACBEB}"/>
+                <a16:creationId xmlns:a16="http://schemas.microsoft.com/office/drawing/2014/main" id="{07604EC8-9A63-47C5-B982-159A1647CDDC}"/>
               </a:ext>
             </a:extLst>
           </p:cNvPr>
@@ -5927,7 +5937,7 @@
           <p:cNvPr id="13" name="">
             <a:extLst xmlns:a="http://schemas.openxmlformats.org/drawingml/2006/main">
               <a:ext uri="{FF2B5EF4-FFF2-40B4-BE49-F238E27FC236}">
-                <a16:creationId xmlns:a16="http://schemas.microsoft.com/office/drawing/2014/main" id="{31C9801A-160A-49B1-8BBD-3D87603A0FC4}"/>
+                <a16:creationId xmlns:a16="http://schemas.microsoft.com/office/drawing/2014/main" id="{3172DA59-5B2A-4D0A-B5D2-28DDBFF45AEA}"/>
               </a:ext>
             </a:extLst>
           </p:cNvPr>
@@ -5984,7 +5994,7 @@
           <p:cNvPr id="14" name="">
             <a:extLst xmlns:a="http://schemas.openxmlformats.org/drawingml/2006/main">
               <a:ext uri="{FF2B5EF4-FFF2-40B4-BE49-F238E27FC236}">
-                <a16:creationId xmlns:a16="http://schemas.microsoft.com/office/drawing/2014/main" id="{566F5063-3B7C-460C-83F7-FEA6EFD31CC6}"/>
+                <a16:creationId xmlns:a16="http://schemas.microsoft.com/office/drawing/2014/main" id="{1652B861-BB5B-48DC-9CAE-9CF5A80B4EEE}"/>
               </a:ext>
             </a:extLst>
           </p:cNvPr>
@@ -6041,7 +6051,7 @@
           <p:cNvPr id="15" name="">
             <a:extLst xmlns:a="http://schemas.openxmlformats.org/drawingml/2006/main">
               <a:ext uri="{FF2B5EF4-FFF2-40B4-BE49-F238E27FC236}">
-                <a16:creationId xmlns:a16="http://schemas.microsoft.com/office/drawing/2014/main" id="{DA957B4C-6185-4EA5-9626-B1B713C3C316}"/>
+                <a16:creationId xmlns:a16="http://schemas.microsoft.com/office/drawing/2014/main" id="{27986953-4EE9-4139-BD8C-6F678B73E0DF}"/>
               </a:ext>
             </a:extLst>
           </p:cNvPr>
@@ -6243,7 +6253,7 @@
           <p:cNvPr id="10" name="">
             <a:extLst xmlns:a="http://schemas.openxmlformats.org/drawingml/2006/main">
               <a:ext uri="{FF2B5EF4-FFF2-40B4-BE49-F238E27FC236}">
-                <a16:creationId xmlns:a16="http://schemas.microsoft.com/office/drawing/2014/main" id="{E6A71317-8045-4007-B42D-EA8D37CD446B}"/>
+                <a16:creationId xmlns:a16="http://schemas.microsoft.com/office/drawing/2014/main" id="{DCF03059-0391-4A83-890F-0FCC4E9D98D5}"/>
               </a:ext>
             </a:extLst>
           </p:cNvPr>
@@ -6300,7 +6310,7 @@
           <p:cNvPr id="11" name="">
             <a:extLst xmlns:a="http://schemas.openxmlformats.org/drawingml/2006/main">
               <a:ext uri="{FF2B5EF4-FFF2-40B4-BE49-F238E27FC236}">
-                <a16:creationId xmlns:a16="http://schemas.microsoft.com/office/drawing/2014/main" id="{A95C85BE-97ED-4868-84AC-201A7B9A9495}"/>
+                <a16:creationId xmlns:a16="http://schemas.microsoft.com/office/drawing/2014/main" id="{63196196-AA3E-4568-9664-7BE78073251F}"/>
               </a:ext>
             </a:extLst>
           </p:cNvPr>
@@ -6330,7 +6340,7 @@
           <p:cNvPr id="12" name="">
             <a:extLst xmlns:a="http://schemas.openxmlformats.org/drawingml/2006/main">
               <a:ext uri="{FF2B5EF4-FFF2-40B4-BE49-F238E27FC236}">
-                <a16:creationId xmlns:a16="http://schemas.microsoft.com/office/drawing/2014/main" id="{606F46AD-3E93-4603-96A9-3FB1647FBDBC}"/>
+                <a16:creationId xmlns:a16="http://schemas.microsoft.com/office/drawing/2014/main" id="{192280F4-5443-4984-B643-B231794148A5}"/>
               </a:ext>
             </a:extLst>
           </p:cNvPr>
@@ -6387,7 +6397,7 @@
           <p:cNvPr id="13" name="">
             <a:extLst xmlns:a="http://schemas.openxmlformats.org/drawingml/2006/main">
               <a:ext uri="{FF2B5EF4-FFF2-40B4-BE49-F238E27FC236}">
-                <a16:creationId xmlns:a16="http://schemas.microsoft.com/office/drawing/2014/main" id="{D85EFC7F-3981-4DF7-B68C-B5C0BAD1B5DE}"/>
+                <a16:creationId xmlns:a16="http://schemas.microsoft.com/office/drawing/2014/main" id="{5EBE5927-EE2F-446A-BE93-C8B3209F2EE1}"/>
               </a:ext>
             </a:extLst>
           </p:cNvPr>
@@ -6444,7 +6454,7 @@
           <p:cNvPr id="14" name="">
             <a:extLst xmlns:a="http://schemas.openxmlformats.org/drawingml/2006/main">
               <a:ext uri="{FF2B5EF4-FFF2-40B4-BE49-F238E27FC236}">
-                <a16:creationId xmlns:a16="http://schemas.microsoft.com/office/drawing/2014/main" id="{82969C44-C8A5-43EA-B2A7-6A9B4F956E05}"/>
+                <a16:creationId xmlns:a16="http://schemas.microsoft.com/office/drawing/2014/main" id="{698418DA-FF6D-430B-883B-560E780D6B15}"/>
               </a:ext>
             </a:extLst>
           </p:cNvPr>
@@ -6474,7 +6484,7 @@
           <p:cNvPr id="15" name="">
             <a:extLst xmlns:a="http://schemas.openxmlformats.org/drawingml/2006/main">
               <a:ext uri="{FF2B5EF4-FFF2-40B4-BE49-F238E27FC236}">
-                <a16:creationId xmlns:a16="http://schemas.microsoft.com/office/drawing/2014/main" id="{035B2DC8-17AE-4FE5-B9DD-2FF02ABE94B0}"/>
+                <a16:creationId xmlns:a16="http://schemas.microsoft.com/office/drawing/2014/main" id="{AB68AFF6-24DD-4FC6-84A7-819A371C7402}"/>
               </a:ext>
             </a:extLst>
           </p:cNvPr>
@@ -6531,7 +6541,7 @@
           <p:cNvPr id="16" name="">
             <a:extLst xmlns:a="http://schemas.openxmlformats.org/drawingml/2006/main">
               <a:ext uri="{FF2B5EF4-FFF2-40B4-BE49-F238E27FC236}">
-                <a16:creationId xmlns:a16="http://schemas.microsoft.com/office/drawing/2014/main" id="{D4AC4927-77EC-43D6-8627-DEA7A20411AE}"/>
+                <a16:creationId xmlns:a16="http://schemas.microsoft.com/office/drawing/2014/main" id="{A250BA4F-D1ED-40EF-9285-7C0A257E0F15}"/>
               </a:ext>
             </a:extLst>
           </p:cNvPr>
@@ -6588,7 +6598,7 @@
           <p:cNvPr id="17" name="">
             <a:extLst xmlns:a="http://schemas.openxmlformats.org/drawingml/2006/main">
               <a:ext uri="{FF2B5EF4-FFF2-40B4-BE49-F238E27FC236}">
-                <a16:creationId xmlns:a16="http://schemas.microsoft.com/office/drawing/2014/main" id="{27FA2032-D8C7-4AA8-8CB7-26D813B93388}"/>
+                <a16:creationId xmlns:a16="http://schemas.microsoft.com/office/drawing/2014/main" id="{CB3BF749-0D70-4A91-8C94-A9CC4A0A46F4}"/>
               </a:ext>
             </a:extLst>
           </p:cNvPr>
@@ -6618,7 +6628,7 @@
           <p:cNvPr id="18" name="">
             <a:extLst xmlns:a="http://schemas.openxmlformats.org/drawingml/2006/main">
               <a:ext uri="{FF2B5EF4-FFF2-40B4-BE49-F238E27FC236}">
-                <a16:creationId xmlns:a16="http://schemas.microsoft.com/office/drawing/2014/main" id="{D26A9AE6-D6BA-4D73-B88F-579449665E40}"/>
+                <a16:creationId xmlns:a16="http://schemas.microsoft.com/office/drawing/2014/main" id="{E5AE9219-7B9B-4AF3-961B-F0978889D220}"/>
               </a:ext>
             </a:extLst>
           </p:cNvPr>
@@ -6675,7 +6685,7 @@
           <p:cNvPr id="19" name="">
             <a:extLst xmlns:a="http://schemas.openxmlformats.org/drawingml/2006/main">
               <a:ext uri="{FF2B5EF4-FFF2-40B4-BE49-F238E27FC236}">
-                <a16:creationId xmlns:a16="http://schemas.microsoft.com/office/drawing/2014/main" id="{8F028823-1298-4A56-B230-7EAB6E6C7982}"/>
+                <a16:creationId xmlns:a16="http://schemas.microsoft.com/office/drawing/2014/main" id="{85BF417F-98D0-44FF-BE75-2D7099D96C74}"/>
               </a:ext>
             </a:extLst>
           </p:cNvPr>
@@ -6732,7 +6742,7 @@
           <p:cNvPr id="20" name="">
             <a:extLst xmlns:a="http://schemas.openxmlformats.org/drawingml/2006/main">
               <a:ext uri="{FF2B5EF4-FFF2-40B4-BE49-F238E27FC236}">
-                <a16:creationId xmlns:a16="http://schemas.microsoft.com/office/drawing/2014/main" id="{3E76ED54-FA54-40F9-8CA3-261ED95C4C1A}"/>
+                <a16:creationId xmlns:a16="http://schemas.microsoft.com/office/drawing/2014/main" id="{7D4F7670-0DCD-4BF3-8218-CA6EF15BCB36}"/>
               </a:ext>
             </a:extLst>
           </p:cNvPr>
@@ -6762,7 +6772,7 @@
           <p:cNvPr id="21" name="">
             <a:extLst xmlns:a="http://schemas.openxmlformats.org/drawingml/2006/main">
               <a:ext uri="{FF2B5EF4-FFF2-40B4-BE49-F238E27FC236}">
-                <a16:creationId xmlns:a16="http://schemas.microsoft.com/office/drawing/2014/main" id="{F0FC325E-6AFC-4736-8B08-71B8B43781B6}"/>
+                <a16:creationId xmlns:a16="http://schemas.microsoft.com/office/drawing/2014/main" id="{6AF66B96-E01A-4AF4-BB75-29847B594967}"/>
               </a:ext>
             </a:extLst>
           </p:cNvPr>
@@ -6819,7 +6829,7 @@
           <p:cNvPr id="22" name="">
             <a:extLst xmlns:a="http://schemas.openxmlformats.org/drawingml/2006/main">
               <a:ext uri="{FF2B5EF4-FFF2-40B4-BE49-F238E27FC236}">
-                <a16:creationId xmlns:a16="http://schemas.microsoft.com/office/drawing/2014/main" id="{D5FF924E-EE68-41EE-A673-C5AC1582C807}"/>
+                <a16:creationId xmlns:a16="http://schemas.microsoft.com/office/drawing/2014/main" id="{BE12D6B2-AA0A-4DFB-B83D-94B17C634589}"/>
               </a:ext>
             </a:extLst>
           </p:cNvPr>
@@ -6951,7 +6961,7 @@
           <p:cNvPr id="26" name="">
             <a:extLst xmlns:a="http://schemas.openxmlformats.org/drawingml/2006/main">
               <a:ext uri="{FF2B5EF4-FFF2-40B4-BE49-F238E27FC236}">
-                <a16:creationId xmlns:a16="http://schemas.microsoft.com/office/drawing/2014/main" id="{3687BE8D-AFAA-48BC-9A32-4146B8961D32}"/>
+                <a16:creationId xmlns:a16="http://schemas.microsoft.com/office/drawing/2014/main" id="{751269A1-C0FB-4555-B751-EFA2885B8BF4}"/>
               </a:ext>
             </a:extLst>
           </p:cNvPr>
@@ -7153,7 +7163,7 @@
           <p:cNvPr id="9" name="">
             <a:extLst xmlns:a="http://schemas.openxmlformats.org/drawingml/2006/main">
               <a:ext uri="{FF2B5EF4-FFF2-40B4-BE49-F238E27FC236}">
-                <a16:creationId xmlns:a16="http://schemas.microsoft.com/office/drawing/2014/main" id="{009A7D96-C94B-47F9-BC68-3C5721AA5BD8}"/>
+                <a16:creationId xmlns:a16="http://schemas.microsoft.com/office/drawing/2014/main" id="{05855FEF-D00B-4F3B-9063-0A374731EF35}"/>
               </a:ext>
             </a:extLst>
           </p:cNvPr>
@@ -7210,7 +7220,7 @@
           <p:cNvPr id="10" name="">
             <a:extLst xmlns:a="http://schemas.openxmlformats.org/drawingml/2006/main">
               <a:ext uri="{FF2B5EF4-FFF2-40B4-BE49-F238E27FC236}">
-                <a16:creationId xmlns:a16="http://schemas.microsoft.com/office/drawing/2014/main" id="{AE990C9C-7940-47A8-8006-EEEEE553175B}"/>
+                <a16:creationId xmlns:a16="http://schemas.microsoft.com/office/drawing/2014/main" id="{5D7C9CEC-B94C-480C-B376-2949BF66DA3F}"/>
               </a:ext>
             </a:extLst>
           </p:cNvPr>
@@ -7267,7 +7277,7 @@
           <p:cNvPr id="11" name="">
             <a:extLst xmlns:a="http://schemas.openxmlformats.org/drawingml/2006/main">
               <a:ext uri="{FF2B5EF4-FFF2-40B4-BE49-F238E27FC236}">
-                <a16:creationId xmlns:a16="http://schemas.microsoft.com/office/drawing/2014/main" id="{C28F98F5-3944-4330-BEE9-79AAE1CF7E2F}"/>
+                <a16:creationId xmlns:a16="http://schemas.microsoft.com/office/drawing/2014/main" id="{0020929D-738A-416F-BED2-E47C8D4D15E8}"/>
               </a:ext>
             </a:extLst>
           </p:cNvPr>
@@ -7347,7 +7357,7 @@
           <p:cNvPr id="12" name="">
             <a:extLst xmlns:a="http://schemas.openxmlformats.org/drawingml/2006/main">
               <a:ext uri="{FF2B5EF4-FFF2-40B4-BE49-F238E27FC236}">
-                <a16:creationId xmlns:a16="http://schemas.microsoft.com/office/drawing/2014/main" id="{6C7729E3-F53A-435A-AF8A-D5A80C07CF9B}"/>
+                <a16:creationId xmlns:a16="http://schemas.microsoft.com/office/drawing/2014/main" id="{31281F73-AED9-4B98-BA8E-0078017FB4BF}"/>
               </a:ext>
             </a:extLst>
           </p:cNvPr>
@@ -7404,7 +7414,7 @@
           <p:cNvPr id="13" name="">
             <a:extLst xmlns:a="http://schemas.openxmlformats.org/drawingml/2006/main">
               <a:ext uri="{FF2B5EF4-FFF2-40B4-BE49-F238E27FC236}">
-                <a16:creationId xmlns:a16="http://schemas.microsoft.com/office/drawing/2014/main" id="{F828DF59-B05D-4A92-B6DC-1503CAD1BD50}"/>
+                <a16:creationId xmlns:a16="http://schemas.microsoft.com/office/drawing/2014/main" id="{BECF7BA0-FA32-4EC4-97D4-1252A26E72AA}"/>
               </a:ext>
             </a:extLst>
           </p:cNvPr>
@@ -7461,7 +7471,7 @@
           <p:cNvPr id="14" name="">
             <a:extLst xmlns:a="http://schemas.openxmlformats.org/drawingml/2006/main">
               <a:ext uri="{FF2B5EF4-FFF2-40B4-BE49-F238E27FC236}">
-                <a16:creationId xmlns:a16="http://schemas.microsoft.com/office/drawing/2014/main" id="{1A5DE226-2768-4320-93BE-E6DD0BDA1F4E}"/>
+                <a16:creationId xmlns:a16="http://schemas.microsoft.com/office/drawing/2014/main" id="{40AF9576-D245-40E4-A727-FF1944D58649}"/>
               </a:ext>
             </a:extLst>
           </p:cNvPr>
@@ -7541,7 +7551,7 @@
           <p:cNvPr id="15" name="">
             <a:extLst xmlns:a="http://schemas.openxmlformats.org/drawingml/2006/main">
               <a:ext uri="{FF2B5EF4-FFF2-40B4-BE49-F238E27FC236}">
-                <a16:creationId xmlns:a16="http://schemas.microsoft.com/office/drawing/2014/main" id="{35B7C575-5395-4BAC-A6BE-217861D02856}"/>
+                <a16:creationId xmlns:a16="http://schemas.microsoft.com/office/drawing/2014/main" id="{2E29B037-0458-4D81-8043-9288AB50118E}"/>
               </a:ext>
             </a:extLst>
           </p:cNvPr>
@@ -7743,7 +7753,7 @@
           <p:cNvPr id="16" name="">
             <a:extLst xmlns:a="http://schemas.openxmlformats.org/drawingml/2006/main">
               <a:ext uri="{FF2B5EF4-FFF2-40B4-BE49-F238E27FC236}">
-                <a16:creationId xmlns:a16="http://schemas.microsoft.com/office/drawing/2014/main" id="{B8BC6FAE-83E9-4AB9-9BD8-F14D784926E3}"/>
+                <a16:creationId xmlns:a16="http://schemas.microsoft.com/office/drawing/2014/main" id="{93180249-2713-419D-81DE-BFFA60BA5A7A}"/>
               </a:ext>
             </a:extLst>
           </p:cNvPr>
@@ -7800,7 +7810,7 @@
           <p:cNvPr id="17" name="">
             <a:extLst xmlns:a="http://schemas.openxmlformats.org/drawingml/2006/main">
               <a:ext uri="{FF2B5EF4-FFF2-40B4-BE49-F238E27FC236}">
-                <a16:creationId xmlns:a16="http://schemas.microsoft.com/office/drawing/2014/main" id="{3AADFA6D-C693-4EA0-A02E-C4CE2BD3A107}"/>
+                <a16:creationId xmlns:a16="http://schemas.microsoft.com/office/drawing/2014/main" id="{B8EF69BA-564B-4957-8B42-CE9A64BC7698}"/>
               </a:ext>
             </a:extLst>
           </p:cNvPr>
@@ -7857,7 +7867,7 @@
           <p:cNvPr id="18" name="">
             <a:extLst xmlns:a="http://schemas.openxmlformats.org/drawingml/2006/main">
               <a:ext uri="{FF2B5EF4-FFF2-40B4-BE49-F238E27FC236}">
-                <a16:creationId xmlns:a16="http://schemas.microsoft.com/office/drawing/2014/main" id="{4EAE18D1-017A-4CD4-8BA6-B3A61BD369B2}"/>
+                <a16:creationId xmlns:a16="http://schemas.microsoft.com/office/drawing/2014/main" id="{D72D409B-66CF-4619-8B95-A6CF62D385D0}"/>
               </a:ext>
             </a:extLst>
           </p:cNvPr>
@@ -7914,7 +7924,7 @@
           <p:cNvPr id="19" name="">
             <a:extLst xmlns:a="http://schemas.openxmlformats.org/drawingml/2006/main">
               <a:ext uri="{FF2B5EF4-FFF2-40B4-BE49-F238E27FC236}">
-                <a16:creationId xmlns:a16="http://schemas.microsoft.com/office/drawing/2014/main" id="{9E4E1165-98BD-4562-968C-B3000B8A4843}"/>
+                <a16:creationId xmlns:a16="http://schemas.microsoft.com/office/drawing/2014/main" id="{E3357217-278C-4E25-B096-FA73868EDA04}"/>
               </a:ext>
             </a:extLst>
           </p:cNvPr>
@@ -7971,7 +7981,7 @@
           <p:cNvPr id="20" name="">
             <a:extLst xmlns:a="http://schemas.openxmlformats.org/drawingml/2006/main">
               <a:ext uri="{FF2B5EF4-FFF2-40B4-BE49-F238E27FC236}">
-                <a16:creationId xmlns:a16="http://schemas.microsoft.com/office/drawing/2014/main" id="{AAF46055-2B5F-4DF1-9219-181C383810CC}"/>
+                <a16:creationId xmlns:a16="http://schemas.microsoft.com/office/drawing/2014/main" id="{1B0CACF6-ABB9-4AB6-A722-35CAEE1F5711}"/>
               </a:ext>
             </a:extLst>
           </p:cNvPr>
@@ -8051,7 +8061,7 @@
           <p:cNvPr id="21" name="">
             <a:extLst xmlns:a="http://schemas.openxmlformats.org/drawingml/2006/main">
               <a:ext uri="{FF2B5EF4-FFF2-40B4-BE49-F238E27FC236}">
-                <a16:creationId xmlns:a16="http://schemas.microsoft.com/office/drawing/2014/main" id="{61F3D9E3-5F73-451A-9C89-62CCA55D0836}"/>
+                <a16:creationId xmlns:a16="http://schemas.microsoft.com/office/drawing/2014/main" id="{BC94E949-BFCC-4D71-A634-E79137542236}"/>
               </a:ext>
             </a:extLst>
           </p:cNvPr>
@@ -8131,7 +8141,7 @@
           <p:cNvPr id="22" name="">
             <a:extLst xmlns:a="http://schemas.openxmlformats.org/drawingml/2006/main">
               <a:ext uri="{FF2B5EF4-FFF2-40B4-BE49-F238E27FC236}">
-                <a16:creationId xmlns:a16="http://schemas.microsoft.com/office/drawing/2014/main" id="{5D1D3AB7-89B9-4F88-828A-3CE1607A506D}"/>
+                <a16:creationId xmlns:a16="http://schemas.microsoft.com/office/drawing/2014/main" id="{AD0B16A8-D04D-4EFA-A062-4555AD32F898}"/>
               </a:ext>
             </a:extLst>
           </p:cNvPr>
@@ -8333,7 +8343,7 @@
           <p:cNvPr id="9" name="">
             <a:extLst xmlns:a="http://schemas.openxmlformats.org/drawingml/2006/main">
               <a:ext uri="{FF2B5EF4-FFF2-40B4-BE49-F238E27FC236}">
-                <a16:creationId xmlns:a16="http://schemas.microsoft.com/office/drawing/2014/main" id="{A107B207-AAD2-454C-ABAE-137CEE2E8225}"/>
+                <a16:creationId xmlns:a16="http://schemas.microsoft.com/office/drawing/2014/main" id="{6B81F07F-5CF5-4BD5-927B-23B0AD866EAF}"/>
               </a:ext>
             </a:extLst>
           </p:cNvPr>
@@ -8397,7 +8407,7 @@
         </p:xfrm>
         <a:graphic xmlns:a="http://schemas.openxmlformats.org/drawingml/2006/main">
           <a:graphicData uri="http://schemas.openxmlformats.org/drawingml/2006/chart">
-            <c:chart xmlns:r="http://schemas.openxmlformats.org/officeDocument/2006/relationships" xmlns:c="http://schemas.openxmlformats.org/drawingml/2006/chart" r:id="R987c10b1c828440a"/>
+            <c:chart xmlns:r="http://schemas.openxmlformats.org/officeDocument/2006/relationships" xmlns:c="http://schemas.openxmlformats.org/drawingml/2006/chart" r:id="Re83353b9a9c84250"/>
           </a:graphicData>
         </a:graphic>
       </p:graphicFrame>
@@ -8406,7 +8416,7 @@
           <p:cNvPr id="11" name="">
             <a:extLst xmlns:a="http://schemas.openxmlformats.org/drawingml/2006/main">
               <a:ext uri="{FF2B5EF4-FFF2-40B4-BE49-F238E27FC236}">
-                <a16:creationId xmlns:a16="http://schemas.microsoft.com/office/drawing/2014/main" id="{DCE79339-7193-4694-B075-B29B8D49509A}"/>
+                <a16:creationId xmlns:a16="http://schemas.microsoft.com/office/drawing/2014/main" id="{0897047A-5F23-4874-A3CA-3A60B6B9E50B}"/>
               </a:ext>
             </a:extLst>
           </p:cNvPr>
@@ -8470,7 +8480,7 @@
         </p:xfrm>
         <a:graphic xmlns:a="http://schemas.openxmlformats.org/drawingml/2006/main">
           <a:graphicData uri="http://schemas.openxmlformats.org/drawingml/2006/chart">
-            <c:chart xmlns:r="http://schemas.openxmlformats.org/officeDocument/2006/relationships" xmlns:c="http://schemas.openxmlformats.org/drawingml/2006/chart" r:id="Rfdf8f35ef5404a48"/>
+            <c:chart xmlns:r="http://schemas.openxmlformats.org/officeDocument/2006/relationships" xmlns:c="http://schemas.openxmlformats.org/drawingml/2006/chart" r:id="Re357c2922d5f44f6"/>
           </a:graphicData>
         </a:graphic>
       </p:graphicFrame>
@@ -8479,7 +8489,7 @@
           <p:cNvPr id="13" name="">
             <a:extLst xmlns:a="http://schemas.openxmlformats.org/drawingml/2006/main">
               <a:ext uri="{FF2B5EF4-FFF2-40B4-BE49-F238E27FC236}">
-                <a16:creationId xmlns:a16="http://schemas.microsoft.com/office/drawing/2014/main" id="{67CB6977-3E76-448F-92C2-86FFDCA14F7E}"/>
+                <a16:creationId xmlns:a16="http://schemas.microsoft.com/office/drawing/2014/main" id="{7AAC9FBC-D497-42DF-B0DE-F011D72326B8}"/>
               </a:ext>
             </a:extLst>
           </p:cNvPr>
@@ -8536,7 +8546,7 @@
           <p:cNvPr id="14" name="">
             <a:extLst xmlns:a="http://schemas.openxmlformats.org/drawingml/2006/main">
               <a:ext uri="{FF2B5EF4-FFF2-40B4-BE49-F238E27FC236}">
-                <a16:creationId xmlns:a16="http://schemas.microsoft.com/office/drawing/2014/main" id="{DAD5C3F5-B527-48FB-B3F2-DA3CAA51F547}"/>
+                <a16:creationId xmlns:a16="http://schemas.microsoft.com/office/drawing/2014/main" id="{5DE38FDB-C23F-4EC5-9158-6D476BEFBD4D}"/>
               </a:ext>
             </a:extLst>
           </p:cNvPr>
@@ -8593,7 +8603,7 @@
           <p:cNvPr id="15" name="">
             <a:extLst xmlns:a="http://schemas.openxmlformats.org/drawingml/2006/main">
               <a:ext uri="{FF2B5EF4-FFF2-40B4-BE49-F238E27FC236}">
-                <a16:creationId xmlns:a16="http://schemas.microsoft.com/office/drawing/2014/main" id="{238B3BC5-AFA4-491F-867C-10C7E070647B}"/>
+                <a16:creationId xmlns:a16="http://schemas.microsoft.com/office/drawing/2014/main" id="{E50D6CF6-8423-495B-BC3F-C3B180CC4000}"/>
               </a:ext>
             </a:extLst>
           </p:cNvPr>
@@ -8673,7 +8683,7 @@
           <p:cNvPr id="16" name="">
             <a:extLst xmlns:a="http://schemas.openxmlformats.org/drawingml/2006/main">
               <a:ext uri="{FF2B5EF4-FFF2-40B4-BE49-F238E27FC236}">
-                <a16:creationId xmlns:a16="http://schemas.microsoft.com/office/drawing/2014/main" id="{C02BFDD9-F4E5-44A8-97D3-8263C8132A9E}"/>
+                <a16:creationId xmlns:a16="http://schemas.microsoft.com/office/drawing/2014/main" id="{B5549B8F-C844-47F5-AA78-1BDB88A772B3}"/>
               </a:ext>
             </a:extLst>
           </p:cNvPr>
@@ -8776,7 +8786,7 @@
           <p:cNvPr id="17" name="">
             <a:extLst xmlns:a="http://schemas.openxmlformats.org/drawingml/2006/main">
               <a:ext uri="{FF2B5EF4-FFF2-40B4-BE49-F238E27FC236}">
-                <a16:creationId xmlns:a16="http://schemas.microsoft.com/office/drawing/2014/main" id="{306E1FE8-DDB4-40AB-BF3F-4FC3BAE75AE1}"/>
+                <a16:creationId xmlns:a16="http://schemas.microsoft.com/office/drawing/2014/main" id="{4F1EE801-C734-4095-BFD6-8EEFAFAFF4F8}"/>
               </a:ext>
             </a:extLst>
           </p:cNvPr>
@@ -8982,7 +8992,7 @@
           <p:nvPr/>
         </p:nvPicPr>
         <p:blipFill>
-          <a:blip xmlns:r="http://schemas.openxmlformats.org/officeDocument/2006/relationships" xmlns:a="http://schemas.openxmlformats.org/drawingml/2006/main" r:embed="R72b517264dda43ef"/>
+          <a:blip xmlns:r="http://schemas.openxmlformats.org/officeDocument/2006/relationships" xmlns:a="http://schemas.openxmlformats.org/drawingml/2006/main" r:embed="Rb1ce7811d13b4ac6"/>
           <a:stretch xmlns:a="http://schemas.openxmlformats.org/drawingml/2006/main"/>
         </p:blipFill>
         <p:spPr>
@@ -9000,7 +9010,7 @@
           <p:cNvPr id="11" name="">
             <a:extLst xmlns:a="http://schemas.openxmlformats.org/drawingml/2006/main">
               <a:ext uri="{FF2B5EF4-FFF2-40B4-BE49-F238E27FC236}">
-                <a16:creationId xmlns:a16="http://schemas.microsoft.com/office/drawing/2014/main" id="{A53DF54B-BA76-4FA8-A16F-C029B0D448B4}"/>
+                <a16:creationId xmlns:a16="http://schemas.microsoft.com/office/drawing/2014/main" id="{F9C8CAA8-788D-4548-91F7-C5DEB807AF34}"/>
               </a:ext>
             </a:extLst>
           </p:cNvPr>
@@ -9057,7 +9067,7 @@
           <p:cNvPr id="12" name="">
             <a:extLst xmlns:a="http://schemas.openxmlformats.org/drawingml/2006/main">
               <a:ext uri="{FF2B5EF4-FFF2-40B4-BE49-F238E27FC236}">
-                <a16:creationId xmlns:a16="http://schemas.microsoft.com/office/drawing/2014/main" id="{5BBBA872-17BC-4A2D-886B-A62118915E1C}"/>
+                <a16:creationId xmlns:a16="http://schemas.microsoft.com/office/drawing/2014/main" id="{55CDD634-26F1-4FD1-9705-8D41430459F6}"/>
               </a:ext>
             </a:extLst>
           </p:cNvPr>
@@ -9114,7 +9124,7 @@
           <p:cNvPr id="13" name="">
             <a:extLst xmlns:a="http://schemas.openxmlformats.org/drawingml/2006/main">
               <a:ext uri="{FF2B5EF4-FFF2-40B4-BE49-F238E27FC236}">
-                <a16:creationId xmlns:a16="http://schemas.microsoft.com/office/drawing/2014/main" id="{9C3A43A4-FFE0-4917-87F1-EEB5CD6948A2}"/>
+                <a16:creationId xmlns:a16="http://schemas.microsoft.com/office/drawing/2014/main" id="{9114EA6B-ED3A-4ECB-ACEB-C4D7A2CE73AE}"/>
               </a:ext>
             </a:extLst>
           </p:cNvPr>
@@ -9171,7 +9181,7 @@
           <p:cNvPr id="14" name="">
             <a:extLst xmlns:a="http://schemas.openxmlformats.org/drawingml/2006/main">
               <a:ext uri="{FF2B5EF4-FFF2-40B4-BE49-F238E27FC236}">
-                <a16:creationId xmlns:a16="http://schemas.microsoft.com/office/drawing/2014/main" id="{0C8C2FF5-9420-447D-A6EC-10E71F3301F4}"/>
+                <a16:creationId xmlns:a16="http://schemas.microsoft.com/office/drawing/2014/main" id="{390D8B8C-C52F-4B9A-B209-D2278ACFE48D}"/>
               </a:ext>
             </a:extLst>
           </p:cNvPr>
@@ -9228,7 +9238,7 @@
           <p:cNvPr id="15" name="">
             <a:extLst xmlns:a="http://schemas.openxmlformats.org/drawingml/2006/main">
               <a:ext uri="{FF2B5EF4-FFF2-40B4-BE49-F238E27FC236}">
-                <a16:creationId xmlns:a16="http://schemas.microsoft.com/office/drawing/2014/main" id="{24D46066-5C88-4F1E-8247-0306B27BE00E}"/>
+                <a16:creationId xmlns:a16="http://schemas.microsoft.com/office/drawing/2014/main" id="{C6221B06-FD03-46FF-B503-50A0FEFE082F}"/>
               </a:ext>
             </a:extLst>
           </p:cNvPr>
@@ -9285,7 +9295,7 @@
           <p:cNvPr id="16" name="">
             <a:extLst xmlns:a="http://schemas.openxmlformats.org/drawingml/2006/main">
               <a:ext uri="{FF2B5EF4-FFF2-40B4-BE49-F238E27FC236}">
-                <a16:creationId xmlns:a16="http://schemas.microsoft.com/office/drawing/2014/main" id="{E0ED39E6-6022-4251-ACC2-6913E1E780FF}"/>
+                <a16:creationId xmlns:a16="http://schemas.microsoft.com/office/drawing/2014/main" id="{942C5E28-D546-4E3A-8126-D3ADDD0B3F8E}"/>
               </a:ext>
             </a:extLst>
           </p:cNvPr>
@@ -9342,7 +9352,7 @@
           <p:cNvPr id="17" name="">
             <a:extLst xmlns:a="http://schemas.openxmlformats.org/drawingml/2006/main">
               <a:ext uri="{FF2B5EF4-FFF2-40B4-BE49-F238E27FC236}">
-                <a16:creationId xmlns:a16="http://schemas.microsoft.com/office/drawing/2014/main" id="{574A7A59-78CD-418A-8AE3-B34EE8C510EB}"/>
+                <a16:creationId xmlns:a16="http://schemas.microsoft.com/office/drawing/2014/main" id="{9CEE45F1-9A4F-4972-B3E2-CFDB264F5909}"/>
               </a:ext>
             </a:extLst>
           </p:cNvPr>
@@ -9389,7 +9399,7 @@
                 <a:ea typeface="Arial"/>
                 <a:cs typeface="Arial"/>
               </a:rPr>
-              <a:t>aktina-pafos-2026.vercel.app     Offline fallback: 60-second silent walkthrough</a:t>
+              <a:t>44-second silent backup. Historical screenshots, before the current forecast view.</a:t>
             </a:r>
           </a:p>
         </p:txBody>
@@ -9544,7 +9554,7 @@
           <p:cNvPr id="9" name="">
             <a:extLst xmlns:a="http://schemas.openxmlformats.org/drawingml/2006/main">
               <a:ext uri="{FF2B5EF4-FFF2-40B4-BE49-F238E27FC236}">
-                <a16:creationId xmlns:a16="http://schemas.microsoft.com/office/drawing/2014/main" id="{513AB02D-0B94-4882-A35F-FA8598B08767}"/>
+                <a16:creationId xmlns:a16="http://schemas.microsoft.com/office/drawing/2014/main" id="{FF10EFA5-F3E4-417F-8D07-0F526B43F571}"/>
               </a:ext>
             </a:extLst>
           </p:cNvPr>
@@ -9608,7 +9618,7 @@
         </p:xfrm>
         <a:graphic xmlns:a="http://schemas.openxmlformats.org/drawingml/2006/main">
           <a:graphicData uri="http://schemas.openxmlformats.org/drawingml/2006/chart">
-            <c:chart xmlns:r="http://schemas.openxmlformats.org/officeDocument/2006/relationships" xmlns:c="http://schemas.openxmlformats.org/drawingml/2006/chart" r:id="Rfea1d8115c5749e7"/>
+            <c:chart xmlns:r="http://schemas.openxmlformats.org/officeDocument/2006/relationships" xmlns:c="http://schemas.openxmlformats.org/drawingml/2006/chart" r:id="Rb94d26cf7554488c"/>
           </a:graphicData>
         </a:graphic>
       </p:graphicFrame>
@@ -9617,7 +9627,7 @@
           <p:cNvPr id="11" name="">
             <a:extLst xmlns:a="http://schemas.openxmlformats.org/drawingml/2006/main">
               <a:ext uri="{FF2B5EF4-FFF2-40B4-BE49-F238E27FC236}">
-                <a16:creationId xmlns:a16="http://schemas.microsoft.com/office/drawing/2014/main" id="{92E31E48-832F-4230-9D8A-F7BE4373D679}"/>
+                <a16:creationId xmlns:a16="http://schemas.microsoft.com/office/drawing/2014/main" id="{A55CC352-F069-43EC-AD16-8FBA1CCC756E}"/>
               </a:ext>
             </a:extLst>
           </p:cNvPr>
@@ -9674,7 +9684,7 @@
           <p:cNvPr id="12" name="">
             <a:extLst xmlns:a="http://schemas.openxmlformats.org/drawingml/2006/main">
               <a:ext uri="{FF2B5EF4-FFF2-40B4-BE49-F238E27FC236}">
-                <a16:creationId xmlns:a16="http://schemas.microsoft.com/office/drawing/2014/main" id="{84B560FF-B22A-42C6-AAF0-3C643809690C}"/>
+                <a16:creationId xmlns:a16="http://schemas.microsoft.com/office/drawing/2014/main" id="{52CA93EF-BB44-4EC1-9D86-AE2FD1A0C787}"/>
               </a:ext>
             </a:extLst>
           </p:cNvPr>
@@ -9754,7 +9764,7 @@
           <p:cNvPr id="13" name="">
             <a:extLst xmlns:a="http://schemas.openxmlformats.org/drawingml/2006/main">
               <a:ext uri="{FF2B5EF4-FFF2-40B4-BE49-F238E27FC236}">
-                <a16:creationId xmlns:a16="http://schemas.microsoft.com/office/drawing/2014/main" id="{1EFF133B-0D8F-440E-A9A6-4DD0A1D16F6C}"/>
+                <a16:creationId xmlns:a16="http://schemas.microsoft.com/office/drawing/2014/main" id="{71708663-1437-4D86-8C73-03A3933EBD92}"/>
               </a:ext>
             </a:extLst>
           </p:cNvPr>
@@ -9834,7 +9844,7 @@
           <p:cNvPr id="14" name="">
             <a:extLst xmlns:a="http://schemas.openxmlformats.org/drawingml/2006/main">
               <a:ext uri="{FF2B5EF4-FFF2-40B4-BE49-F238E27FC236}">
-                <a16:creationId xmlns:a16="http://schemas.microsoft.com/office/drawing/2014/main" id="{C7D01F09-3660-4721-9A7F-74352FCEE2BE}"/>
+                <a16:creationId xmlns:a16="http://schemas.microsoft.com/office/drawing/2014/main" id="{CE4BFB54-4802-46FD-873B-1B3B3A0B589A}"/>
               </a:ext>
             </a:extLst>
           </p:cNvPr>
@@ -10036,7 +10046,7 @@
           <p:cNvPr id="10" name="">
             <a:extLst xmlns:a="http://schemas.openxmlformats.org/drawingml/2006/main">
               <a:ext uri="{FF2B5EF4-FFF2-40B4-BE49-F238E27FC236}">
-                <a16:creationId xmlns:a16="http://schemas.microsoft.com/office/drawing/2014/main" id="{760CA6A7-2B26-4AF4-A11C-CC8BA03FC848}"/>
+                <a16:creationId xmlns:a16="http://schemas.microsoft.com/office/drawing/2014/main" id="{EAA86208-A7D2-411D-BE45-2355D361E6BB}"/>
               </a:ext>
             </a:extLst>
           </p:cNvPr>
@@ -10100,7 +10110,7 @@
         </p:xfrm>
         <a:graphic xmlns:a="http://schemas.openxmlformats.org/drawingml/2006/main">
           <a:graphicData uri="http://schemas.openxmlformats.org/drawingml/2006/chart">
-            <c:chart xmlns:r="http://schemas.openxmlformats.org/officeDocument/2006/relationships" xmlns:c="http://schemas.openxmlformats.org/drawingml/2006/chart" r:id="R4f709f97844f4c63"/>
+            <c:chart xmlns:r="http://schemas.openxmlformats.org/officeDocument/2006/relationships" xmlns:c="http://schemas.openxmlformats.org/drawingml/2006/chart" r:id="R313aaba4287741c5"/>
           </a:graphicData>
         </a:graphic>
       </p:graphicFrame>
@@ -10525,7 +10535,7 @@
           <p:cNvPr id="13" name="">
             <a:extLst xmlns:a="http://schemas.openxmlformats.org/drawingml/2006/main">
               <a:ext uri="{FF2B5EF4-FFF2-40B4-BE49-F238E27FC236}">
-                <a16:creationId xmlns:a16="http://schemas.microsoft.com/office/drawing/2014/main" id="{53CE39CA-ADB6-46B9-AE79-ADA9D47D0555}"/>
+                <a16:creationId xmlns:a16="http://schemas.microsoft.com/office/drawing/2014/main" id="{C86E15DD-FA2B-4E6E-ABC7-8BBCCD3921C9}"/>
               </a:ext>
             </a:extLst>
           </p:cNvPr>
@@ -10582,7 +10592,7 @@
           <p:cNvPr id="14" name="">
             <a:extLst xmlns:a="http://schemas.openxmlformats.org/drawingml/2006/main">
               <a:ext uri="{FF2B5EF4-FFF2-40B4-BE49-F238E27FC236}">
-                <a16:creationId xmlns:a16="http://schemas.microsoft.com/office/drawing/2014/main" id="{05EE4F9B-FA34-4A74-A566-BDB5DF35D1D2}"/>
+                <a16:creationId xmlns:a16="http://schemas.microsoft.com/office/drawing/2014/main" id="{B7CF74BC-0082-4A37-861A-79319BFF5E18}"/>
               </a:ext>
             </a:extLst>
           </p:cNvPr>
@@ -10784,7 +10794,7 @@
           <p:cNvPr id="10" name="">
             <a:extLst xmlns:a="http://schemas.openxmlformats.org/drawingml/2006/main">
               <a:ext uri="{FF2B5EF4-FFF2-40B4-BE49-F238E27FC236}">
-                <a16:creationId xmlns:a16="http://schemas.microsoft.com/office/drawing/2014/main" id="{C5409487-9299-4234-99D0-DB9E3EBDE018}"/>
+                <a16:creationId xmlns:a16="http://schemas.microsoft.com/office/drawing/2014/main" id="{BB1D92F4-CCF8-434E-B32D-EB20EF5329BC}"/>
               </a:ext>
             </a:extLst>
           </p:cNvPr>
@@ -10841,7 +10851,7 @@
           <p:cNvPr id="11" name="">
             <a:extLst xmlns:a="http://schemas.openxmlformats.org/drawingml/2006/main">
               <a:ext uri="{FF2B5EF4-FFF2-40B4-BE49-F238E27FC236}">
-                <a16:creationId xmlns:a16="http://schemas.microsoft.com/office/drawing/2014/main" id="{8FBC7EC8-8BC8-4DF1-9DFA-E6205E406F46}"/>
+                <a16:creationId xmlns:a16="http://schemas.microsoft.com/office/drawing/2014/main" id="{D61D83B9-6DF8-4272-AFB0-33BCB8DBB7ED}"/>
               </a:ext>
             </a:extLst>
           </p:cNvPr>
@@ -10921,7 +10931,7 @@
           <p:cNvPr id="12" name="">
             <a:extLst xmlns:a="http://schemas.openxmlformats.org/drawingml/2006/main">
               <a:ext uri="{FF2B5EF4-FFF2-40B4-BE49-F238E27FC236}">
-                <a16:creationId xmlns:a16="http://schemas.microsoft.com/office/drawing/2014/main" id="{E33C2971-1024-4D30-9373-778A7DE70437}"/>
+                <a16:creationId xmlns:a16="http://schemas.microsoft.com/office/drawing/2014/main" id="{826837B7-B6E1-482C-8FBA-D52BB2FE701B}"/>
               </a:ext>
             </a:extLst>
           </p:cNvPr>
@@ -10978,7 +10988,7 @@
           <p:cNvPr id="13" name="">
             <a:extLst xmlns:a="http://schemas.openxmlformats.org/drawingml/2006/main">
               <a:ext uri="{FF2B5EF4-FFF2-40B4-BE49-F238E27FC236}">
-                <a16:creationId xmlns:a16="http://schemas.microsoft.com/office/drawing/2014/main" id="{BDC0D349-EA96-4298-BFAA-109990948B80}"/>
+                <a16:creationId xmlns:a16="http://schemas.microsoft.com/office/drawing/2014/main" id="{BDB97D19-8AA1-4654-8472-7C32DB8CA214}"/>
               </a:ext>
             </a:extLst>
           </p:cNvPr>
@@ -11058,7 +11068,7 @@
           <p:cNvPr id="14" name="">
             <a:extLst xmlns:a="http://schemas.openxmlformats.org/drawingml/2006/main">
               <a:ext uri="{FF2B5EF4-FFF2-40B4-BE49-F238E27FC236}">
-                <a16:creationId xmlns:a16="http://schemas.microsoft.com/office/drawing/2014/main" id="{B230E63E-137B-490F-868C-A0F19345D1B4}"/>
+                <a16:creationId xmlns:a16="http://schemas.microsoft.com/office/drawing/2014/main" id="{CD4C4E8C-FE8C-4C2E-95BD-3DF85F93FC99}"/>
               </a:ext>
             </a:extLst>
           </p:cNvPr>
@@ -11115,7 +11125,7 @@
           <p:cNvPr id="15" name="">
             <a:extLst xmlns:a="http://schemas.openxmlformats.org/drawingml/2006/main">
               <a:ext uri="{FF2B5EF4-FFF2-40B4-BE49-F238E27FC236}">
-                <a16:creationId xmlns:a16="http://schemas.microsoft.com/office/drawing/2014/main" id="{59088507-36BF-4623-8899-DED7B636F9A3}"/>
+                <a16:creationId xmlns:a16="http://schemas.microsoft.com/office/drawing/2014/main" id="{D5E3AB58-0C85-4FFA-BD39-96224260DB07}"/>
               </a:ext>
             </a:extLst>
           </p:cNvPr>

</xml_diff>